<commit_message>
Add PPTX generation script and update presentation copy
Adds scripts/generate-pptx.js (pptxgenjs + sharp) to regenerate the
editable PPTX deck alongside the existing PDF script, and refreshes
the hero copy and group-format slide with the event-specific offer.

Co-Authored-By: Claude Sonnet 5 <noreply@anthropic.com>
</commit_message>
<xml_diff>
--- a/apresentacao.pptx
+++ b/apresentacao.pptx
@@ -2056,7 +2056,7 @@
         </p:nvSpPr>
         <p:spPr>
           <a:xfrm>
-            <a:off x="548640" y="1920240"/>
+            <a:off x="548640" y="1828800"/>
             <a:ext cx="5120640" cy="457200"/>
           </a:xfrm>
           <a:prstGeom prst="roundRect">
@@ -2085,7 +2085,7 @@
         </p:nvSpPr>
         <p:spPr>
           <a:xfrm>
-            <a:off x="685800" y="1920240"/>
+            <a:off x="685800" y="1828800"/>
             <a:ext cx="5029200" cy="457200"/>
           </a:xfrm>
           <a:prstGeom prst="rect">
@@ -2121,8 +2121,8 @@
         </p:nvSpPr>
         <p:spPr>
           <a:xfrm>
-            <a:off x="548640" y="2514600"/>
-            <a:ext cx="9601200" cy="1645920"/>
+            <a:off x="548640" y="2423160"/>
+            <a:ext cx="10789920" cy="1737360"/>
           </a:xfrm>
           <a:prstGeom prst="rect">
             <a:avLst/>
@@ -2136,33 +2136,33 @@
           <a:p>
             <a:pPr indent="0" marL="0">
               <a:lnSpc>
-                <a:spcPts val="4400"/>
+                <a:spcPts val="3600"/>
               </a:lnSpc>
               <a:buNone/>
             </a:pPr>
             <a:r>
-              <a:rPr lang="en-US" sz="4000" b="1" dirty="0">
+              <a:rPr lang="en-US" sz="3200" b="1" dirty="0">
                 <a:solidFill>
                   <a:srgbClr val="FFFFFF"/>
                 </a:solidFill>
               </a:rPr>
-              <a:t>O negócio está crescendo, e você sente que precisa </a:t>
+              <a:t>Você quer construir um negócio que trabalha a favor da sua vida… </a:t>
             </a:r>
             <a:pPr indent="0" marL="0">
               <a:lnSpc>
-                <a:spcPts val="4400"/>
+                <a:spcPts val="3600"/>
               </a:lnSpc>
               <a:buNone/>
             </a:pPr>
             <a:r>
-              <a:rPr lang="en-US" sz="4000" b="1" dirty="0">
+              <a:rPr lang="en-US" sz="3200" b="1" dirty="0">
                 <a:solidFill>
                   <a:srgbClr val="60A5FA"/>
                 </a:solidFill>
               </a:rPr>
-              <a:t>crescer junto?</a:t>
-            </a:r>
-            <a:endParaRPr lang="en-US" sz="4000" dirty="0"/>
+              <a:t>ou uma vida que trabalha para o seu negócio?</a:t>
+            </a:r>
+            <a:endParaRPr lang="en-US" sz="3200" dirty="0"/>
           </a:p>
         </p:txBody>
       </p:sp>
@@ -2174,8 +2174,8 @@
         </p:nvSpPr>
         <p:spPr>
           <a:xfrm>
-            <a:off x="548640" y="4160520"/>
-            <a:ext cx="7863840" cy="914400"/>
+            <a:off x="548640" y="4251960"/>
+            <a:ext cx="9875520" cy="1005840"/>
           </a:xfrm>
           <a:prstGeom prst="rect">
             <a:avLst/>
@@ -2189,19 +2189,19 @@
           <a:p>
             <a:pPr indent="0" marL="0">
               <a:lnSpc>
-                <a:spcPts val="2100"/>
+                <a:spcPts val="1900"/>
               </a:lnSpc>
               <a:buNone/>
             </a:pPr>
             <a:r>
-              <a:rPr lang="en-US" sz="1500" dirty="0">
+              <a:rPr lang="en-US" sz="1350" dirty="0">
                 <a:solidFill>
                   <a:srgbClr val="CBD5E1"/>
                 </a:solidFill>
               </a:rPr>
-              <a:t>Em 8 semanas, desenvolva clareza, foco e capacidades de liderança para conduzir a próxima fase do seu negócio — sem perder o que é importante para você.</a:t>
-            </a:r>
-            <a:endParaRPr lang="en-US" sz="1500" dirty="0"/>
+              <a:t>Seja para viabilizar uma ideia, tracionar sua startup ou estruturar o crescimento da sua empresa. Em 8 semanas, desenvolva a clareza, a liderança e a estratégia (OKRs) necessárias para conduzir a próxima fase do seu negócio — sem deixar a sua vida para trás.</a:t>
+            </a:r>
+            <a:endParaRPr lang="en-US" sz="1350" dirty="0"/>
           </a:p>
         </p:txBody>
       </p:sp>
@@ -3155,7 +3155,7 @@
       </p:sp>
       <p:pic>
         <p:nvPicPr>
-          <p:cNvPr id="6" name="Image 0" descr="C:\Users\jaasa\AppData\Local\Temp\claude\c--Dev-escala-voce\acec037a-a87b-4f5a-a10e-0610f51ce7dc\scratchpad\pptx-gen\perfil-marina.png">    </p:cNvPr>
+          <p:cNvPr id="6" name="Image 0" descr="preencoded.png">    </p:cNvPr>
           <p:cNvPicPr>
             <a:picLocks noChangeAspect="1"/>
           </p:cNvPicPr>
@@ -3416,7 +3416,7 @@
       </p:sp>
       <p:pic>
         <p:nvPicPr>
-          <p:cNvPr id="11" name="Image 1" descr="C:\Users\jaasa\AppData\Local\Temp\claude\c--Dev-escala-voce\acec037a-a87b-4f5a-a10e-0610f51ce7dc\scratchpad\pptx-gen\perfil-jose.png">    </p:cNvPr>
+          <p:cNvPr id="11" name="Image 1" descr="preencoded.png">    </p:cNvPr>
           <p:cNvPicPr>
             <a:picLocks noChangeAspect="1"/>
           </p:cNvPicPr>
@@ -4429,7 +4429,7 @@
         <p:spPr>
           <a:xfrm>
             <a:off x="731520" y="502920"/>
-            <a:ext cx="7315200" cy="320040"/>
+            <a:ext cx="4572000" cy="274320"/>
           </a:xfrm>
           <a:prstGeom prst="rect">
             <a:avLst/>
@@ -4445,14 +4445,14 @@
               <a:buNone/>
             </a:pPr>
             <a:r>
-              <a:rPr lang="en-US" sz="1300" b="1" spc="200" kern="0" dirty="0">
+              <a:rPr lang="en-US" sz="1200" b="1" spc="200" kern="0" dirty="0">
                 <a:solidFill>
                   <a:srgbClr val="2563EB"/>
                 </a:solidFill>
               </a:rPr>
               <a:t>FUNDAMENTO</a:t>
             </a:r>
-            <a:endParaRPr lang="en-US" sz="1300" dirty="0"/>
+            <a:endParaRPr lang="en-US" sz="1200" dirty="0"/>
           </a:p>
         </p:txBody>
       </p:sp>
@@ -9080,6 +9080,1528 @@
     <p:bg>
       <p:bgPr>
         <a:solidFill>
+          <a:srgbClr val="FFFFFF"/>
+        </a:solidFill>
+      </p:bgPr>
+    </p:bg>
+    <p:spTree>
+      <p:nvGrpSpPr>
+        <p:cNvPr id="1" name=""/>
+        <p:cNvGrpSpPr/>
+        <p:nvPr/>
+      </p:nvGrpSpPr>
+      <p:grpSpPr>
+        <a:xfrm>
+          <a:off x="0" y="0"/>
+          <a:ext cx="0" cy="0"/>
+          <a:chOff x="0" y="0"/>
+          <a:chExt cx="0" cy="0"/>
+        </a:xfrm>
+      </p:grpSpPr>
+      <p:sp>
+        <p:nvSpPr>
+          <p:cNvPr id="2" name="Text 0"/>
+          <p:cNvSpPr/>
+          <p:nvPr/>
+        </p:nvSpPr>
+        <p:spPr>
+          <a:xfrm>
+            <a:off x="0" y="274320"/>
+            <a:ext cx="12191695" cy="274320"/>
+          </a:xfrm>
+          <a:prstGeom prst="rect">
+            <a:avLst/>
+          </a:prstGeom>
+          <a:noFill/>
+          <a:ln/>
+        </p:spPr>
+        <p:txBody>
+          <a:bodyPr wrap="square" rtlCol="0" anchor="ctr"/>
+          <a:lstStyle/>
+          <a:p>
+            <a:pPr algn="ctr" indent="0" marL="0">
+              <a:buNone/>
+            </a:pPr>
+            <a:r>
+              <a:rPr lang="en-US" sz="1200" b="1" spc="200" kern="0" dirty="0">
+                <a:solidFill>
+                  <a:srgbClr val="2563EB"/>
+                </a:solidFill>
+              </a:rPr>
+              <a:t>COMO FUNCIONA</a:t>
+            </a:r>
+            <a:endParaRPr lang="en-US" sz="1200" dirty="0"/>
+          </a:p>
+        </p:txBody>
+      </p:sp>
+      <p:sp>
+        <p:nvSpPr>
+          <p:cNvPr id="3" name="Text 1"/>
+          <p:cNvSpPr/>
+          <p:nvPr/>
+        </p:nvSpPr>
+        <p:spPr>
+          <a:xfrm>
+            <a:off x="0" y="530352"/>
+            <a:ext cx="12191695" cy="457200"/>
+          </a:xfrm>
+          <a:prstGeom prst="rect">
+            <a:avLst/>
+          </a:prstGeom>
+          <a:noFill/>
+          <a:ln/>
+        </p:spPr>
+        <p:txBody>
+          <a:bodyPr wrap="square" rtlCol="0" anchor="ctr"/>
+          <a:lstStyle/>
+          <a:p>
+            <a:pPr algn="ctr" indent="0" marL="0">
+              <a:buNone/>
+            </a:pPr>
+            <a:r>
+              <a:rPr lang="en-US" sz="2600" b="1" dirty="0">
+                <a:solidFill>
+                  <a:srgbClr val="0F172A"/>
+                </a:solidFill>
+              </a:rPr>
+              <a:t>Formato individual</a:t>
+            </a:r>
+            <a:endParaRPr lang="en-US" sz="2600" dirty="0"/>
+          </a:p>
+        </p:txBody>
+      </p:sp>
+      <p:sp>
+        <p:nvSpPr>
+          <p:cNvPr id="4" name="Shape 2"/>
+          <p:cNvSpPr/>
+          <p:nvPr/>
+        </p:nvSpPr>
+        <p:spPr>
+          <a:xfrm>
+            <a:off x="5775808" y="1024128"/>
+            <a:ext cx="640080" cy="54864"/>
+          </a:xfrm>
+          <a:prstGeom prst="roundRect">
+            <a:avLst>
+              <a:gd name="adj" fmla="val 50000"/>
+            </a:avLst>
+          </a:prstGeom>
+          <a:solidFill>
+            <a:srgbClr val="2563EB"/>
+          </a:solidFill>
+          <a:ln/>
+        </p:spPr>
+      </p:sp>
+      <p:sp>
+        <p:nvSpPr>
+          <p:cNvPr id="5" name="Shape 3"/>
+          <p:cNvSpPr/>
+          <p:nvPr/>
+        </p:nvSpPr>
+        <p:spPr>
+          <a:xfrm>
+            <a:off x="792328" y="1325880"/>
+            <a:ext cx="3383280" cy="640080"/>
+          </a:xfrm>
+          <a:prstGeom prst="roundRect">
+            <a:avLst>
+              <a:gd name="adj" fmla="val 17143"/>
+            </a:avLst>
+          </a:prstGeom>
+          <a:solidFill>
+            <a:srgbClr val="1D4ED8"/>
+          </a:solidFill>
+          <a:ln/>
+        </p:spPr>
+      </p:sp>
+      <p:sp>
+        <p:nvSpPr>
+          <p:cNvPr id="6" name="Text 4"/>
+          <p:cNvSpPr/>
+          <p:nvPr/>
+        </p:nvSpPr>
+        <p:spPr>
+          <a:xfrm>
+            <a:off x="975208" y="1399032"/>
+            <a:ext cx="3017520" cy="228600"/>
+          </a:xfrm>
+          <a:prstGeom prst="rect">
+            <a:avLst/>
+          </a:prstGeom>
+          <a:noFill/>
+          <a:ln/>
+        </p:spPr>
+        <p:txBody>
+          <a:bodyPr wrap="square" rtlCol="0" anchor="ctr"/>
+          <a:lstStyle/>
+          <a:p>
+            <a:pPr indent="0" marL="0">
+              <a:buNone/>
+            </a:pPr>
+            <a:r>
+              <a:rPr lang="en-US" sz="950" dirty="0">
+                <a:solidFill>
+                  <a:srgbClr val="BFDBFE"/>
+                </a:solidFill>
+              </a:rPr>
+              <a:t>Duração total</a:t>
+            </a:r>
+            <a:endParaRPr lang="en-US" sz="950" dirty="0"/>
+          </a:p>
+        </p:txBody>
+      </p:sp>
+      <p:sp>
+        <p:nvSpPr>
+          <p:cNvPr id="7" name="Text 5"/>
+          <p:cNvSpPr/>
+          <p:nvPr/>
+        </p:nvSpPr>
+        <p:spPr>
+          <a:xfrm>
+            <a:off x="975208" y="1618488"/>
+            <a:ext cx="3017520" cy="292608"/>
+          </a:xfrm>
+          <a:prstGeom prst="rect">
+            <a:avLst/>
+          </a:prstGeom>
+          <a:noFill/>
+          <a:ln/>
+        </p:spPr>
+        <p:txBody>
+          <a:bodyPr wrap="square" rtlCol="0" anchor="ctr"/>
+          <a:lstStyle/>
+          <a:p>
+            <a:pPr indent="0" marL="0">
+              <a:buNone/>
+            </a:pPr>
+            <a:r>
+              <a:rPr lang="en-US" sz="1500" b="1" dirty="0">
+                <a:solidFill>
+                  <a:srgbClr val="FFFFFF"/>
+                </a:solidFill>
+              </a:rPr>
+              <a:t>8 semanas</a:t>
+            </a:r>
+            <a:endParaRPr lang="en-US" sz="1500" dirty="0"/>
+          </a:p>
+        </p:txBody>
+      </p:sp>
+      <p:sp>
+        <p:nvSpPr>
+          <p:cNvPr id="8" name="Shape 6"/>
+          <p:cNvSpPr/>
+          <p:nvPr/>
+        </p:nvSpPr>
+        <p:spPr>
+          <a:xfrm>
+            <a:off x="4404208" y="1325880"/>
+            <a:ext cx="3383280" cy="640080"/>
+          </a:xfrm>
+          <a:prstGeom prst="roundRect">
+            <a:avLst>
+              <a:gd name="adj" fmla="val 17143"/>
+            </a:avLst>
+          </a:prstGeom>
+          <a:solidFill>
+            <a:srgbClr val="1D4ED8"/>
+          </a:solidFill>
+          <a:ln/>
+        </p:spPr>
+      </p:sp>
+      <p:sp>
+        <p:nvSpPr>
+          <p:cNvPr id="9" name="Text 7"/>
+          <p:cNvSpPr/>
+          <p:nvPr/>
+        </p:nvSpPr>
+        <p:spPr>
+          <a:xfrm>
+            <a:off x="4587088" y="1399032"/>
+            <a:ext cx="3017520" cy="228600"/>
+          </a:xfrm>
+          <a:prstGeom prst="rect">
+            <a:avLst/>
+          </a:prstGeom>
+          <a:noFill/>
+          <a:ln/>
+        </p:spPr>
+        <p:txBody>
+          <a:bodyPr wrap="square" rtlCol="0" anchor="ctr"/>
+          <a:lstStyle/>
+          <a:p>
+            <a:pPr indent="0" marL="0">
+              <a:buNone/>
+            </a:pPr>
+            <a:r>
+              <a:rPr lang="en-US" sz="950" dirty="0">
+                <a:solidFill>
+                  <a:srgbClr val="BFDBFE"/>
+                </a:solidFill>
+              </a:rPr>
+              <a:t>Total de encontros</a:t>
+            </a:r>
+            <a:endParaRPr lang="en-US" sz="950" dirty="0"/>
+          </a:p>
+        </p:txBody>
+      </p:sp>
+      <p:sp>
+        <p:nvSpPr>
+          <p:cNvPr id="10" name="Text 8"/>
+          <p:cNvSpPr/>
+          <p:nvPr/>
+        </p:nvSpPr>
+        <p:spPr>
+          <a:xfrm>
+            <a:off x="4587088" y="1618488"/>
+            <a:ext cx="3017520" cy="292608"/>
+          </a:xfrm>
+          <a:prstGeom prst="rect">
+            <a:avLst/>
+          </a:prstGeom>
+          <a:noFill/>
+          <a:ln/>
+        </p:spPr>
+        <p:txBody>
+          <a:bodyPr wrap="square" rtlCol="0" anchor="ctr"/>
+          <a:lstStyle/>
+          <a:p>
+            <a:pPr indent="0" marL="0">
+              <a:buNone/>
+            </a:pPr>
+            <a:r>
+              <a:rPr lang="en-US" sz="1500" b="1" dirty="0">
+                <a:solidFill>
+                  <a:srgbClr val="FFFFFF"/>
+                </a:solidFill>
+              </a:rPr>
+              <a:t>7 encontros</a:t>
+            </a:r>
+            <a:endParaRPr lang="en-US" sz="1500" dirty="0"/>
+          </a:p>
+        </p:txBody>
+      </p:sp>
+      <p:sp>
+        <p:nvSpPr>
+          <p:cNvPr id="11" name="Shape 9"/>
+          <p:cNvSpPr/>
+          <p:nvPr/>
+        </p:nvSpPr>
+        <p:spPr>
+          <a:xfrm>
+            <a:off x="8016088" y="1325880"/>
+            <a:ext cx="3383280" cy="640080"/>
+          </a:xfrm>
+          <a:prstGeom prst="roundRect">
+            <a:avLst>
+              <a:gd name="adj" fmla="val 17143"/>
+            </a:avLst>
+          </a:prstGeom>
+          <a:solidFill>
+            <a:srgbClr val="1D4ED8"/>
+          </a:solidFill>
+          <a:ln/>
+        </p:spPr>
+      </p:sp>
+      <p:sp>
+        <p:nvSpPr>
+          <p:cNvPr id="12" name="Text 10"/>
+          <p:cNvSpPr/>
+          <p:nvPr/>
+        </p:nvSpPr>
+        <p:spPr>
+          <a:xfrm>
+            <a:off x="8198968" y="1399032"/>
+            <a:ext cx="3017520" cy="228600"/>
+          </a:xfrm>
+          <a:prstGeom prst="rect">
+            <a:avLst/>
+          </a:prstGeom>
+          <a:noFill/>
+          <a:ln/>
+        </p:spPr>
+        <p:txBody>
+          <a:bodyPr wrap="square" rtlCol="0" anchor="ctr"/>
+          <a:lstStyle/>
+          <a:p>
+            <a:pPr indent="0" marL="0">
+              <a:buNone/>
+            </a:pPr>
+            <a:r>
+              <a:rPr lang="en-US" sz="950" dirty="0">
+                <a:solidFill>
+                  <a:srgbClr val="BFDBFE"/>
+                </a:solidFill>
+              </a:rPr>
+              <a:t>Duração dos encontros</a:t>
+            </a:r>
+            <a:endParaRPr lang="en-US" sz="950" dirty="0"/>
+          </a:p>
+        </p:txBody>
+      </p:sp>
+      <p:sp>
+        <p:nvSpPr>
+          <p:cNvPr id="13" name="Text 11"/>
+          <p:cNvSpPr/>
+          <p:nvPr/>
+        </p:nvSpPr>
+        <p:spPr>
+          <a:xfrm>
+            <a:off x="8198968" y="1618488"/>
+            <a:ext cx="3017520" cy="292608"/>
+          </a:xfrm>
+          <a:prstGeom prst="rect">
+            <a:avLst/>
+          </a:prstGeom>
+          <a:noFill/>
+          <a:ln/>
+        </p:spPr>
+        <p:txBody>
+          <a:bodyPr wrap="square" rtlCol="0" anchor="ctr"/>
+          <a:lstStyle/>
+          <a:p>
+            <a:pPr indent="0" marL="0">
+              <a:buNone/>
+            </a:pPr>
+            <a:r>
+              <a:rPr lang="en-US" sz="1500" b="1" dirty="0">
+                <a:solidFill>
+                  <a:srgbClr val="FFFFFF"/>
+                </a:solidFill>
+              </a:rPr>
+              <a:t>1,5h cada</a:t>
+            </a:r>
+            <a:endParaRPr lang="en-US" sz="1500" dirty="0"/>
+          </a:p>
+        </p:txBody>
+      </p:sp>
+      <p:sp>
+        <p:nvSpPr>
+          <p:cNvPr id="14" name="Shape 12"/>
+          <p:cNvSpPr/>
+          <p:nvPr/>
+        </p:nvSpPr>
+        <p:spPr>
+          <a:xfrm>
+            <a:off x="792328" y="2148840"/>
+            <a:ext cx="3383280" cy="3154680"/>
+          </a:xfrm>
+          <a:prstGeom prst="roundRect">
+            <a:avLst>
+              <a:gd name="adj" fmla="val 3478"/>
+            </a:avLst>
+          </a:prstGeom>
+          <a:solidFill>
+            <a:srgbClr val="FFFFFF"/>
+          </a:solidFill>
+          <a:ln w="12700">
+            <a:solidFill>
+              <a:srgbClr val="F1F5F9"/>
+            </a:solidFill>
+            <a:prstDash val="solid"/>
+          </a:ln>
+          <a:effectLst>
+            <a:outerShdw sx="100000" sy="100000" kx="0" ky="0" algn="bl" rotWithShape="0" blurRad="101600" dist="38100" dir="5400000">
+              <a:srgbClr val="000000">
+                <a:alpha val="8000"/>
+              </a:srgbClr>
+            </a:outerShdw>
+          </a:effectLst>
+        </p:spPr>
+      </p:sp>
+      <p:sp>
+        <p:nvSpPr>
+          <p:cNvPr id="15" name="Shape 13"/>
+          <p:cNvSpPr/>
+          <p:nvPr/>
+        </p:nvSpPr>
+        <p:spPr>
+          <a:xfrm>
+            <a:off x="1020928" y="2377440"/>
+            <a:ext cx="502920" cy="502920"/>
+          </a:xfrm>
+          <a:prstGeom prst="roundRect">
+            <a:avLst>
+              <a:gd name="adj" fmla="val 21818"/>
+            </a:avLst>
+          </a:prstGeom>
+          <a:solidFill>
+            <a:srgbClr val="EFF6FF"/>
+          </a:solidFill>
+          <a:ln/>
+        </p:spPr>
+      </p:sp>
+      <p:sp>
+        <p:nvSpPr>
+          <p:cNvPr id="16" name="Text 14"/>
+          <p:cNvSpPr/>
+          <p:nvPr/>
+        </p:nvSpPr>
+        <p:spPr>
+          <a:xfrm>
+            <a:off x="1020928" y="2377440"/>
+            <a:ext cx="502920" cy="502920"/>
+          </a:xfrm>
+          <a:prstGeom prst="rect">
+            <a:avLst/>
+          </a:prstGeom>
+          <a:noFill/>
+          <a:ln/>
+        </p:spPr>
+        <p:txBody>
+          <a:bodyPr wrap="square" rtlCol="0" anchor="ctr"/>
+          <a:lstStyle/>
+          <a:p>
+            <a:pPr algn="ctr" indent="0" marL="0">
+              <a:buNone/>
+            </a:pPr>
+            <a:r>
+              <a:rPr lang="en-US" sz="1600" dirty="0">
+                <a:solidFill>
+                  <a:srgbClr val="000000"/>
+                </a:solidFill>
+              </a:rPr>
+              <a:t>👤</a:t>
+            </a:r>
+            <a:endParaRPr lang="en-US" sz="1600" dirty="0"/>
+          </a:p>
+        </p:txBody>
+      </p:sp>
+      <p:sp>
+        <p:nvSpPr>
+          <p:cNvPr id="17" name="Text 15"/>
+          <p:cNvSpPr/>
+          <p:nvPr/>
+        </p:nvSpPr>
+        <p:spPr>
+          <a:xfrm>
+            <a:off x="1020928" y="2971800"/>
+            <a:ext cx="2926080" cy="228600"/>
+          </a:xfrm>
+          <a:prstGeom prst="rect">
+            <a:avLst/>
+          </a:prstGeom>
+          <a:noFill/>
+          <a:ln/>
+        </p:spPr>
+        <p:txBody>
+          <a:bodyPr wrap="square" rtlCol="0" anchor="ctr"/>
+          <a:lstStyle/>
+          <a:p>
+            <a:pPr indent="0" marL="0">
+              <a:buNone/>
+            </a:pPr>
+            <a:r>
+              <a:rPr lang="en-US" sz="950" b="1" spc="100" kern="0" dirty="0">
+                <a:solidFill>
+                  <a:srgbClr val="1D4ED8"/>
+                </a:solidFill>
+              </a:rPr>
+              <a:t>MÓDULO 1</a:t>
+            </a:r>
+            <a:endParaRPr lang="en-US" sz="950" dirty="0"/>
+          </a:p>
+        </p:txBody>
+      </p:sp>
+      <p:sp>
+        <p:nvSpPr>
+          <p:cNvPr id="18" name="Text 16"/>
+          <p:cNvSpPr/>
+          <p:nvPr/>
+        </p:nvSpPr>
+        <p:spPr>
+          <a:xfrm>
+            <a:off x="1020928" y="3200400"/>
+            <a:ext cx="2926080" cy="640080"/>
+          </a:xfrm>
+          <a:prstGeom prst="rect">
+            <a:avLst/>
+          </a:prstGeom>
+          <a:noFill/>
+          <a:ln/>
+        </p:spPr>
+        <p:txBody>
+          <a:bodyPr wrap="square" rtlCol="0" anchor="ctr"/>
+          <a:lstStyle/>
+          <a:p>
+            <a:pPr indent="0" marL="0">
+              <a:buNone/>
+            </a:pPr>
+            <a:r>
+              <a:rPr lang="en-US" sz="1450" b="1" dirty="0">
+                <a:solidFill>
+                  <a:srgbClr val="0F172A"/>
+                </a:solidFill>
+              </a:rPr>
+              <a:t>Quem sou como empreendedor?</a:t>
+            </a:r>
+            <a:endParaRPr lang="en-US" sz="1450" dirty="0"/>
+          </a:p>
+        </p:txBody>
+      </p:sp>
+      <p:sp>
+        <p:nvSpPr>
+          <p:cNvPr id="19" name="Text 17"/>
+          <p:cNvSpPr/>
+          <p:nvPr/>
+        </p:nvSpPr>
+        <p:spPr>
+          <a:xfrm>
+            <a:off x="1020928" y="3840480"/>
+            <a:ext cx="2926080" cy="685800"/>
+          </a:xfrm>
+          <a:prstGeom prst="rect">
+            <a:avLst/>
+          </a:prstGeom>
+          <a:noFill/>
+          <a:ln/>
+        </p:spPr>
+        <p:txBody>
+          <a:bodyPr wrap="square" rtlCol="0" anchor="ctr"/>
+          <a:lstStyle/>
+          <a:p>
+            <a:pPr marL="342900" indent="-342900">
+              <a:lnSpc>
+                <a:spcPts val="1500"/>
+              </a:lnSpc>
+              <a:buSzPct val="100000"/>
+              <a:buChar char="•"/>
+            </a:pPr>
+            <a:r>
+              <a:rPr lang="en-US" sz="1050" dirty="0">
+                <a:solidFill>
+                  <a:srgbClr val="475569"/>
+                </a:solidFill>
+              </a:rPr>
+              <a:t>4 encontros · 3 assessments</a:t>
+            </a:r>
+            <a:endParaRPr lang="en-US" sz="1050" dirty="0"/>
+          </a:p>
+          <a:p>
+            <a:pPr marL="342900" indent="-342900">
+              <a:lnSpc>
+                <a:spcPts val="1500"/>
+              </a:lnSpc>
+              <a:buSzPct val="100000"/>
+              <a:buChar char="•"/>
+            </a:pPr>
+            <a:r>
+              <a:rPr lang="en-US" sz="1050" dirty="0">
+                <a:solidFill>
+                  <a:srgbClr val="475569"/>
+                </a:solidFill>
+              </a:rPr>
+              <a:t>Duração: 4 semanas</a:t>
+            </a:r>
+            <a:endParaRPr lang="en-US" sz="1050" dirty="0"/>
+          </a:p>
+        </p:txBody>
+      </p:sp>
+      <p:sp>
+        <p:nvSpPr>
+          <p:cNvPr id="20" name="Shape 18"/>
+          <p:cNvSpPr/>
+          <p:nvPr/>
+        </p:nvSpPr>
+        <p:spPr>
+          <a:xfrm>
+            <a:off x="1020928" y="4389120"/>
+            <a:ext cx="2926080" cy="731520"/>
+          </a:xfrm>
+          <a:prstGeom prst="roundRect">
+            <a:avLst>
+              <a:gd name="adj" fmla="val 15000"/>
+            </a:avLst>
+          </a:prstGeom>
+          <a:solidFill>
+            <a:srgbClr val="F8FAFC"/>
+          </a:solidFill>
+          <a:ln/>
+        </p:spPr>
+      </p:sp>
+      <p:sp>
+        <p:nvSpPr>
+          <p:cNvPr id="21" name="Text 19"/>
+          <p:cNvSpPr/>
+          <p:nvPr/>
+        </p:nvSpPr>
+        <p:spPr>
+          <a:xfrm>
+            <a:off x="1158088" y="4462272"/>
+            <a:ext cx="2651760" cy="201168"/>
+          </a:xfrm>
+          <a:prstGeom prst="rect">
+            <a:avLst/>
+          </a:prstGeom>
+          <a:noFill/>
+          <a:ln/>
+        </p:spPr>
+        <p:txBody>
+          <a:bodyPr wrap="square" rtlCol="0" anchor="ctr"/>
+          <a:lstStyle/>
+          <a:p>
+            <a:pPr indent="0" marL="0">
+              <a:buNone/>
+            </a:pPr>
+            <a:r>
+              <a:rPr lang="en-US" sz="900" dirty="0">
+                <a:solidFill>
+                  <a:srgbClr val="64748B"/>
+                </a:solidFill>
+              </a:rPr>
+              <a:t>Investimento</a:t>
+            </a:r>
+            <a:endParaRPr lang="en-US" sz="900" dirty="0"/>
+          </a:p>
+        </p:txBody>
+      </p:sp>
+      <p:sp>
+        <p:nvSpPr>
+          <p:cNvPr id="22" name="Text 20"/>
+          <p:cNvSpPr/>
+          <p:nvPr/>
+        </p:nvSpPr>
+        <p:spPr>
+          <a:xfrm>
+            <a:off x="1158088" y="4645152"/>
+            <a:ext cx="2651760" cy="365760"/>
+          </a:xfrm>
+          <a:prstGeom prst="rect">
+            <a:avLst/>
+          </a:prstGeom>
+          <a:noFill/>
+          <a:ln/>
+        </p:spPr>
+        <p:txBody>
+          <a:bodyPr wrap="square" rtlCol="0" anchor="ctr"/>
+          <a:lstStyle/>
+          <a:p>
+            <a:pPr indent="0" marL="0">
+              <a:buNone/>
+            </a:pPr>
+            <a:r>
+              <a:rPr lang="en-US" sz="2000" b="1" dirty="0">
+                <a:solidFill>
+                  <a:srgbClr val="1D4ED8"/>
+                </a:solidFill>
+              </a:rPr>
+              <a:t>R$ 3.800</a:t>
+            </a:r>
+            <a:endParaRPr lang="en-US" sz="2000" dirty="0"/>
+          </a:p>
+        </p:txBody>
+      </p:sp>
+      <p:sp>
+        <p:nvSpPr>
+          <p:cNvPr id="23" name="Shape 21"/>
+          <p:cNvSpPr/>
+          <p:nvPr/>
+        </p:nvSpPr>
+        <p:spPr>
+          <a:xfrm>
+            <a:off x="4404208" y="2148840"/>
+            <a:ext cx="3383280" cy="3154680"/>
+          </a:xfrm>
+          <a:prstGeom prst="roundRect">
+            <a:avLst>
+              <a:gd name="adj" fmla="val 3478"/>
+            </a:avLst>
+          </a:prstGeom>
+          <a:solidFill>
+            <a:srgbClr val="FFFFFF"/>
+          </a:solidFill>
+          <a:ln w="12700">
+            <a:solidFill>
+              <a:srgbClr val="F1F5F9"/>
+            </a:solidFill>
+            <a:prstDash val="solid"/>
+          </a:ln>
+          <a:effectLst>
+            <a:outerShdw sx="100000" sy="100000" kx="0" ky="0" algn="bl" rotWithShape="0" blurRad="101600" dist="38100" dir="5400000">
+              <a:srgbClr val="000000">
+                <a:alpha val="8000"/>
+              </a:srgbClr>
+            </a:outerShdw>
+          </a:effectLst>
+        </p:spPr>
+      </p:sp>
+      <p:sp>
+        <p:nvSpPr>
+          <p:cNvPr id="24" name="Shape 22"/>
+          <p:cNvSpPr/>
+          <p:nvPr/>
+        </p:nvSpPr>
+        <p:spPr>
+          <a:xfrm>
+            <a:off x="4632808" y="2377440"/>
+            <a:ext cx="502920" cy="502920"/>
+          </a:xfrm>
+          <a:prstGeom prst="roundRect">
+            <a:avLst>
+              <a:gd name="adj" fmla="val 21818"/>
+            </a:avLst>
+          </a:prstGeom>
+          <a:solidFill>
+            <a:srgbClr val="EEF2FF"/>
+          </a:solidFill>
+          <a:ln/>
+        </p:spPr>
+      </p:sp>
+      <p:sp>
+        <p:nvSpPr>
+          <p:cNvPr id="25" name="Text 23"/>
+          <p:cNvSpPr/>
+          <p:nvPr/>
+        </p:nvSpPr>
+        <p:spPr>
+          <a:xfrm>
+            <a:off x="4632808" y="2377440"/>
+            <a:ext cx="502920" cy="502920"/>
+          </a:xfrm>
+          <a:prstGeom prst="rect">
+            <a:avLst/>
+          </a:prstGeom>
+          <a:noFill/>
+          <a:ln/>
+        </p:spPr>
+        <p:txBody>
+          <a:bodyPr wrap="square" rtlCol="0" anchor="ctr"/>
+          <a:lstStyle/>
+          <a:p>
+            <a:pPr algn="ctr" indent="0" marL="0">
+              <a:buNone/>
+            </a:pPr>
+            <a:r>
+              <a:rPr lang="en-US" sz="1600" dirty="0">
+                <a:solidFill>
+                  <a:srgbClr val="000000"/>
+                </a:solidFill>
+              </a:rPr>
+              <a:t>🎯</a:t>
+            </a:r>
+            <a:endParaRPr lang="en-US" sz="1600" dirty="0"/>
+          </a:p>
+        </p:txBody>
+      </p:sp>
+      <p:sp>
+        <p:nvSpPr>
+          <p:cNvPr id="26" name="Text 24"/>
+          <p:cNvSpPr/>
+          <p:nvPr/>
+        </p:nvSpPr>
+        <p:spPr>
+          <a:xfrm>
+            <a:off x="4632808" y="2971800"/>
+            <a:ext cx="2926080" cy="228600"/>
+          </a:xfrm>
+          <a:prstGeom prst="rect">
+            <a:avLst/>
+          </a:prstGeom>
+          <a:noFill/>
+          <a:ln/>
+        </p:spPr>
+        <p:txBody>
+          <a:bodyPr wrap="square" rtlCol="0" anchor="ctr"/>
+          <a:lstStyle/>
+          <a:p>
+            <a:pPr indent="0" marL="0">
+              <a:buNone/>
+            </a:pPr>
+            <a:r>
+              <a:rPr lang="en-US" sz="950" b="1" spc="100" kern="0" dirty="0">
+                <a:solidFill>
+                  <a:srgbClr val="4338CA"/>
+                </a:solidFill>
+              </a:rPr>
+              <a:t>MÓDULO 2</a:t>
+            </a:r>
+            <a:endParaRPr lang="en-US" sz="950" dirty="0"/>
+          </a:p>
+        </p:txBody>
+      </p:sp>
+      <p:sp>
+        <p:nvSpPr>
+          <p:cNvPr id="27" name="Text 25"/>
+          <p:cNvSpPr/>
+          <p:nvPr/>
+        </p:nvSpPr>
+        <p:spPr>
+          <a:xfrm>
+            <a:off x="4632808" y="3200400"/>
+            <a:ext cx="2926080" cy="640080"/>
+          </a:xfrm>
+          <a:prstGeom prst="rect">
+            <a:avLst/>
+          </a:prstGeom>
+          <a:noFill/>
+          <a:ln/>
+        </p:spPr>
+        <p:txBody>
+          <a:bodyPr wrap="square" rtlCol="0" anchor="ctr"/>
+          <a:lstStyle/>
+          <a:p>
+            <a:pPr indent="0" marL="0">
+              <a:buNone/>
+            </a:pPr>
+            <a:r>
+              <a:rPr lang="en-US" sz="1450" b="1" dirty="0">
+                <a:solidFill>
+                  <a:srgbClr val="0F172A"/>
+                </a:solidFill>
+              </a:rPr>
+              <a:t>Minha estratégia como empreendedor</a:t>
+            </a:r>
+            <a:endParaRPr lang="en-US" sz="1450" dirty="0"/>
+          </a:p>
+        </p:txBody>
+      </p:sp>
+      <p:sp>
+        <p:nvSpPr>
+          <p:cNvPr id="28" name="Text 26"/>
+          <p:cNvSpPr/>
+          <p:nvPr/>
+        </p:nvSpPr>
+        <p:spPr>
+          <a:xfrm>
+            <a:off x="4632808" y="3840480"/>
+            <a:ext cx="2926080" cy="685800"/>
+          </a:xfrm>
+          <a:prstGeom prst="rect">
+            <a:avLst/>
+          </a:prstGeom>
+          <a:noFill/>
+          <a:ln/>
+        </p:spPr>
+        <p:txBody>
+          <a:bodyPr wrap="square" rtlCol="0" anchor="ctr"/>
+          <a:lstStyle/>
+          <a:p>
+            <a:pPr marL="342900" indent="-342900">
+              <a:lnSpc>
+                <a:spcPts val="1500"/>
+              </a:lnSpc>
+              <a:buSzPct val="100000"/>
+              <a:buChar char="•"/>
+            </a:pPr>
+            <a:r>
+              <a:rPr lang="en-US" sz="1050" dirty="0">
+                <a:solidFill>
+                  <a:srgbClr val="475569"/>
+                </a:solidFill>
+              </a:rPr>
+              <a:t>3 encontros</a:t>
+            </a:r>
+            <a:endParaRPr lang="en-US" sz="1050" dirty="0"/>
+          </a:p>
+          <a:p>
+            <a:pPr marL="342900" indent="-342900">
+              <a:lnSpc>
+                <a:spcPts val="1500"/>
+              </a:lnSpc>
+              <a:buSzPct val="100000"/>
+              <a:buChar char="•"/>
+            </a:pPr>
+            <a:r>
+              <a:rPr lang="en-US" sz="1050" dirty="0">
+                <a:solidFill>
+                  <a:srgbClr val="475569"/>
+                </a:solidFill>
+              </a:rPr>
+              <a:t>Duração: 4 semanas</a:t>
+            </a:r>
+            <a:endParaRPr lang="en-US" sz="1050" dirty="0"/>
+          </a:p>
+        </p:txBody>
+      </p:sp>
+      <p:sp>
+        <p:nvSpPr>
+          <p:cNvPr id="29" name="Shape 27"/>
+          <p:cNvSpPr/>
+          <p:nvPr/>
+        </p:nvSpPr>
+        <p:spPr>
+          <a:xfrm>
+            <a:off x="4632808" y="4389120"/>
+            <a:ext cx="2926080" cy="731520"/>
+          </a:xfrm>
+          <a:prstGeom prst="roundRect">
+            <a:avLst>
+              <a:gd name="adj" fmla="val 15000"/>
+            </a:avLst>
+          </a:prstGeom>
+          <a:solidFill>
+            <a:srgbClr val="F8FAFC"/>
+          </a:solidFill>
+          <a:ln/>
+        </p:spPr>
+      </p:sp>
+      <p:sp>
+        <p:nvSpPr>
+          <p:cNvPr id="30" name="Text 28"/>
+          <p:cNvSpPr/>
+          <p:nvPr/>
+        </p:nvSpPr>
+        <p:spPr>
+          <a:xfrm>
+            <a:off x="4769968" y="4462272"/>
+            <a:ext cx="2651760" cy="201168"/>
+          </a:xfrm>
+          <a:prstGeom prst="rect">
+            <a:avLst/>
+          </a:prstGeom>
+          <a:noFill/>
+          <a:ln/>
+        </p:spPr>
+        <p:txBody>
+          <a:bodyPr wrap="square" rtlCol="0" anchor="ctr"/>
+          <a:lstStyle/>
+          <a:p>
+            <a:pPr indent="0" marL="0">
+              <a:buNone/>
+            </a:pPr>
+            <a:r>
+              <a:rPr lang="en-US" sz="900" dirty="0">
+                <a:solidFill>
+                  <a:srgbClr val="64748B"/>
+                </a:solidFill>
+              </a:rPr>
+              <a:t>Investimento</a:t>
+            </a:r>
+            <a:endParaRPr lang="en-US" sz="900" dirty="0"/>
+          </a:p>
+        </p:txBody>
+      </p:sp>
+      <p:sp>
+        <p:nvSpPr>
+          <p:cNvPr id="31" name="Text 29"/>
+          <p:cNvSpPr/>
+          <p:nvPr/>
+        </p:nvSpPr>
+        <p:spPr>
+          <a:xfrm>
+            <a:off x="4769968" y="4645152"/>
+            <a:ext cx="2651760" cy="365760"/>
+          </a:xfrm>
+          <a:prstGeom prst="rect">
+            <a:avLst/>
+          </a:prstGeom>
+          <a:noFill/>
+          <a:ln/>
+        </p:spPr>
+        <p:txBody>
+          <a:bodyPr wrap="square" rtlCol="0" anchor="ctr"/>
+          <a:lstStyle/>
+          <a:p>
+            <a:pPr indent="0" marL="0">
+              <a:buNone/>
+            </a:pPr>
+            <a:r>
+              <a:rPr lang="en-US" sz="2000" b="1" dirty="0">
+                <a:solidFill>
+                  <a:srgbClr val="4338CA"/>
+                </a:solidFill>
+              </a:rPr>
+              <a:t>R$ 2.800</a:t>
+            </a:r>
+            <a:endParaRPr lang="en-US" sz="2000" dirty="0"/>
+          </a:p>
+        </p:txBody>
+      </p:sp>
+      <p:sp>
+        <p:nvSpPr>
+          <p:cNvPr id="32" name="Shape 30"/>
+          <p:cNvSpPr/>
+          <p:nvPr/>
+        </p:nvSpPr>
+        <p:spPr>
+          <a:xfrm>
+            <a:off x="8016088" y="2148840"/>
+            <a:ext cx="3383280" cy="3154680"/>
+          </a:xfrm>
+          <a:prstGeom prst="roundRect">
+            <a:avLst>
+              <a:gd name="adj" fmla="val 3478"/>
+            </a:avLst>
+          </a:prstGeom>
+          <a:solidFill>
+            <a:srgbClr val="EFF6FF"/>
+          </a:solidFill>
+          <a:ln w="19050">
+            <a:solidFill>
+              <a:srgbClr val="2563EB"/>
+            </a:solidFill>
+            <a:prstDash val="solid"/>
+          </a:ln>
+          <a:effectLst>
+            <a:outerShdw sx="100000" sy="100000" kx="0" ky="0" algn="bl" rotWithShape="0" blurRad="101600" dist="38100" dir="5400000">
+              <a:srgbClr val="000000">
+                <a:alpha val="8000"/>
+              </a:srgbClr>
+            </a:outerShdw>
+          </a:effectLst>
+        </p:spPr>
+      </p:sp>
+      <p:sp>
+        <p:nvSpPr>
+          <p:cNvPr id="33" name="Shape 31"/>
+          <p:cNvSpPr/>
+          <p:nvPr/>
+        </p:nvSpPr>
+        <p:spPr>
+          <a:xfrm>
+            <a:off x="9707728" y="1984248"/>
+            <a:ext cx="1554480" cy="329184"/>
+          </a:xfrm>
+          <a:prstGeom prst="roundRect">
+            <a:avLst>
+              <a:gd name="adj" fmla="val 50000"/>
+            </a:avLst>
+          </a:prstGeom>
+          <a:solidFill>
+            <a:srgbClr val="1D4ED8"/>
+          </a:solidFill>
+          <a:ln/>
+        </p:spPr>
+      </p:sp>
+      <p:sp>
+        <p:nvSpPr>
+          <p:cNvPr id="34" name="Text 32"/>
+          <p:cNvSpPr/>
+          <p:nvPr/>
+        </p:nvSpPr>
+        <p:spPr>
+          <a:xfrm>
+            <a:off x="9707728" y="1984248"/>
+            <a:ext cx="1554480" cy="329184"/>
+          </a:xfrm>
+          <a:prstGeom prst="rect">
+            <a:avLst/>
+          </a:prstGeom>
+          <a:noFill/>
+          <a:ln/>
+        </p:spPr>
+        <p:txBody>
+          <a:bodyPr wrap="square" rtlCol="0" anchor="ctr"/>
+          <a:lstStyle/>
+          <a:p>
+            <a:pPr algn="ctr" indent="0" marL="0">
+              <a:buNone/>
+            </a:pPr>
+            <a:r>
+              <a:rPr lang="en-US" sz="800" b="1" dirty="0">
+                <a:solidFill>
+                  <a:srgbClr val="FFFFFF"/>
+                </a:solidFill>
+              </a:rPr>
+              <a:t>MELHOR ESCOLHA</a:t>
+            </a:r>
+            <a:endParaRPr lang="en-US" sz="800" dirty="0"/>
+          </a:p>
+        </p:txBody>
+      </p:sp>
+      <p:sp>
+        <p:nvSpPr>
+          <p:cNvPr id="35" name="Shape 33"/>
+          <p:cNvSpPr/>
+          <p:nvPr/>
+        </p:nvSpPr>
+        <p:spPr>
+          <a:xfrm>
+            <a:off x="8244688" y="2377440"/>
+            <a:ext cx="502920" cy="502920"/>
+          </a:xfrm>
+          <a:prstGeom prst="roundRect">
+            <a:avLst>
+              <a:gd name="adj" fmla="val 21818"/>
+            </a:avLst>
+          </a:prstGeom>
+          <a:solidFill>
+            <a:srgbClr val="2563EB"/>
+          </a:solidFill>
+          <a:ln/>
+        </p:spPr>
+      </p:sp>
+      <p:sp>
+        <p:nvSpPr>
+          <p:cNvPr id="36" name="Text 34"/>
+          <p:cNvSpPr/>
+          <p:nvPr/>
+        </p:nvSpPr>
+        <p:spPr>
+          <a:xfrm>
+            <a:off x="8244688" y="2377440"/>
+            <a:ext cx="502920" cy="502920"/>
+          </a:xfrm>
+          <a:prstGeom prst="rect">
+            <a:avLst/>
+          </a:prstGeom>
+          <a:noFill/>
+          <a:ln/>
+        </p:spPr>
+        <p:txBody>
+          <a:bodyPr wrap="square" rtlCol="0" anchor="ctr"/>
+          <a:lstStyle/>
+          <a:p>
+            <a:pPr algn="ctr" indent="0" marL="0">
+              <a:buNone/>
+            </a:pPr>
+            <a:r>
+              <a:rPr lang="en-US" sz="1600" dirty="0">
+                <a:solidFill>
+                  <a:srgbClr val="000000"/>
+                </a:solidFill>
+              </a:rPr>
+              <a:t>⭐</a:t>
+            </a:r>
+            <a:endParaRPr lang="en-US" sz="1600" dirty="0"/>
+          </a:p>
+        </p:txBody>
+      </p:sp>
+      <p:sp>
+        <p:nvSpPr>
+          <p:cNvPr id="37" name="Text 35"/>
+          <p:cNvSpPr/>
+          <p:nvPr/>
+        </p:nvSpPr>
+        <p:spPr>
+          <a:xfrm>
+            <a:off x="8244688" y="2971800"/>
+            <a:ext cx="2926080" cy="228600"/>
+          </a:xfrm>
+          <a:prstGeom prst="rect">
+            <a:avLst/>
+          </a:prstGeom>
+          <a:noFill/>
+          <a:ln/>
+        </p:spPr>
+        <p:txBody>
+          <a:bodyPr wrap="square" rtlCol="0" anchor="ctr"/>
+          <a:lstStyle/>
+          <a:p>
+            <a:pPr indent="0" marL="0">
+              <a:buNone/>
+            </a:pPr>
+            <a:r>
+              <a:rPr lang="en-US" sz="950" b="1" spc="100" kern="0" dirty="0">
+                <a:solidFill>
+                  <a:srgbClr val="1D4ED8"/>
+                </a:solidFill>
+              </a:rPr>
+              <a:t>MÓDULO 1 + MÓDULO 2</a:t>
+            </a:r>
+            <a:endParaRPr lang="en-US" sz="950" dirty="0"/>
+          </a:p>
+        </p:txBody>
+      </p:sp>
+      <p:sp>
+        <p:nvSpPr>
+          <p:cNvPr id="38" name="Text 36"/>
+          <p:cNvSpPr/>
+          <p:nvPr/>
+        </p:nvSpPr>
+        <p:spPr>
+          <a:xfrm>
+            <a:off x="8244688" y="3200400"/>
+            <a:ext cx="2926080" cy="640080"/>
+          </a:xfrm>
+          <a:prstGeom prst="rect">
+            <a:avLst/>
+          </a:prstGeom>
+          <a:noFill/>
+          <a:ln/>
+        </p:spPr>
+        <p:txBody>
+          <a:bodyPr wrap="square" rtlCol="0" anchor="ctr"/>
+          <a:lstStyle/>
+          <a:p>
+            <a:pPr indent="0" marL="0">
+              <a:buNone/>
+            </a:pPr>
+            <a:r>
+              <a:rPr lang="en-US" sz="1450" b="1" dirty="0">
+                <a:solidFill>
+                  <a:srgbClr val="0F172A"/>
+                </a:solidFill>
+              </a:rPr>
+              <a:t>Programa Completo</a:t>
+            </a:r>
+            <a:endParaRPr lang="en-US" sz="1450" dirty="0"/>
+          </a:p>
+        </p:txBody>
+      </p:sp>
+      <p:sp>
+        <p:nvSpPr>
+          <p:cNvPr id="39" name="Text 37"/>
+          <p:cNvSpPr/>
+          <p:nvPr/>
+        </p:nvSpPr>
+        <p:spPr>
+          <a:xfrm>
+            <a:off x="8244688" y="3840480"/>
+            <a:ext cx="2926080" cy="685800"/>
+          </a:xfrm>
+          <a:prstGeom prst="rect">
+            <a:avLst/>
+          </a:prstGeom>
+          <a:noFill/>
+          <a:ln/>
+        </p:spPr>
+        <p:txBody>
+          <a:bodyPr wrap="square" rtlCol="0" anchor="ctr"/>
+          <a:lstStyle/>
+          <a:p>
+            <a:pPr marL="342900" indent="-342900">
+              <a:lnSpc>
+                <a:spcPts val="1500"/>
+              </a:lnSpc>
+              <a:buSzPct val="100000"/>
+              <a:buChar char="•"/>
+            </a:pPr>
+            <a:r>
+              <a:rPr lang="en-US" sz="1050" dirty="0">
+                <a:solidFill>
+                  <a:srgbClr val="475569"/>
+                </a:solidFill>
+              </a:rPr>
+              <a:t>7 encontros</a:t>
+            </a:r>
+            <a:endParaRPr lang="en-US" sz="1050" dirty="0"/>
+          </a:p>
+          <a:p>
+            <a:pPr marL="342900" indent="-342900">
+              <a:lnSpc>
+                <a:spcPts val="1500"/>
+              </a:lnSpc>
+              <a:buSzPct val="100000"/>
+              <a:buChar char="•"/>
+            </a:pPr>
+            <a:r>
+              <a:rPr lang="en-US" sz="1050" dirty="0">
+                <a:solidFill>
+                  <a:srgbClr val="475569"/>
+                </a:solidFill>
+              </a:rPr>
+              <a:t>Duração: 8 semanas</a:t>
+            </a:r>
+            <a:endParaRPr lang="en-US" sz="1050" dirty="0"/>
+          </a:p>
+        </p:txBody>
+      </p:sp>
+      <p:sp>
+        <p:nvSpPr>
+          <p:cNvPr id="40" name="Shape 38"/>
+          <p:cNvSpPr/>
+          <p:nvPr/>
+        </p:nvSpPr>
+        <p:spPr>
+          <a:xfrm>
+            <a:off x="8244688" y="4389120"/>
+            <a:ext cx="2926080" cy="731520"/>
+          </a:xfrm>
+          <a:prstGeom prst="roundRect">
+            <a:avLst>
+              <a:gd name="adj" fmla="val 15000"/>
+            </a:avLst>
+          </a:prstGeom>
+          <a:solidFill>
+            <a:srgbClr val="FFFFFF"/>
+          </a:solidFill>
+          <a:ln/>
+        </p:spPr>
+      </p:sp>
+      <p:sp>
+        <p:nvSpPr>
+          <p:cNvPr id="41" name="Text 39"/>
+          <p:cNvSpPr/>
+          <p:nvPr/>
+        </p:nvSpPr>
+        <p:spPr>
+          <a:xfrm>
+            <a:off x="8381848" y="4462272"/>
+            <a:ext cx="2651760" cy="201168"/>
+          </a:xfrm>
+          <a:prstGeom prst="rect">
+            <a:avLst/>
+          </a:prstGeom>
+          <a:noFill/>
+          <a:ln/>
+        </p:spPr>
+        <p:txBody>
+          <a:bodyPr wrap="square" rtlCol="0" anchor="ctr"/>
+          <a:lstStyle/>
+          <a:p>
+            <a:pPr indent="0" marL="0">
+              <a:buNone/>
+            </a:pPr>
+            <a:r>
+              <a:rPr lang="en-US" sz="900" dirty="0">
+                <a:solidFill>
+                  <a:srgbClr val="64748B"/>
+                </a:solidFill>
+              </a:rPr>
+              <a:t>Investimento</a:t>
+            </a:r>
+            <a:endParaRPr lang="en-US" sz="900" dirty="0"/>
+          </a:p>
+        </p:txBody>
+      </p:sp>
+      <p:sp>
+        <p:nvSpPr>
+          <p:cNvPr id="42" name="Text 40"/>
+          <p:cNvSpPr/>
+          <p:nvPr/>
+        </p:nvSpPr>
+        <p:spPr>
+          <a:xfrm>
+            <a:off x="8381848" y="4645152"/>
+            <a:ext cx="2651760" cy="365760"/>
+          </a:xfrm>
+          <a:prstGeom prst="rect">
+            <a:avLst/>
+          </a:prstGeom>
+          <a:noFill/>
+          <a:ln/>
+        </p:spPr>
+        <p:txBody>
+          <a:bodyPr wrap="square" rtlCol="0" anchor="ctr"/>
+          <a:lstStyle/>
+          <a:p>
+            <a:pPr indent="0" marL="0">
+              <a:buNone/>
+            </a:pPr>
+            <a:r>
+              <a:rPr lang="en-US" sz="2000" b="1" dirty="0">
+                <a:solidFill>
+                  <a:srgbClr val="1D4ED8"/>
+                </a:solidFill>
+              </a:rPr>
+              <a:t>R$ 6.000</a:t>
+            </a:r>
+            <a:endParaRPr lang="en-US" sz="2000" dirty="0"/>
+          </a:p>
+        </p:txBody>
+      </p:sp>
+      <p:sp>
+        <p:nvSpPr>
+          <p:cNvPr id="43" name="Text 41"/>
+          <p:cNvSpPr/>
+          <p:nvPr/>
+        </p:nvSpPr>
+        <p:spPr>
+          <a:xfrm>
+            <a:off x="8381848" y="5010912"/>
+            <a:ext cx="2651760" cy="228600"/>
+          </a:xfrm>
+          <a:prstGeom prst="rect">
+            <a:avLst/>
+          </a:prstGeom>
+          <a:noFill/>
+          <a:ln/>
+        </p:spPr>
+        <p:txBody>
+          <a:bodyPr wrap="square" rtlCol="0" anchor="ctr"/>
+          <a:lstStyle/>
+          <a:p>
+            <a:pPr indent="0" marL="0">
+              <a:buNone/>
+            </a:pPr>
+            <a:r>
+              <a:rPr lang="en-US" sz="900" b="1" dirty="0">
+                <a:solidFill>
+                  <a:srgbClr val="059669"/>
+                </a:solidFill>
+              </a:rPr>
+              <a:t>✨ Economia de R$ 600</a:t>
+            </a:r>
+            <a:endParaRPr lang="en-US" sz="900" dirty="0"/>
+          </a:p>
+        </p:txBody>
+      </p:sp>
+      <p:sp>
+        <p:nvSpPr>
+          <p:cNvPr id="44" name="Text 42"/>
+          <p:cNvSpPr/>
+          <p:nvPr/>
+        </p:nvSpPr>
+        <p:spPr>
+          <a:xfrm>
+            <a:off x="792328" y="5440680"/>
+            <a:ext cx="10607040" cy="365760"/>
+          </a:xfrm>
+          <a:prstGeom prst="rect">
+            <a:avLst/>
+          </a:prstGeom>
+          <a:noFill/>
+          <a:ln/>
+        </p:spPr>
+        <p:txBody>
+          <a:bodyPr wrap="square" rtlCol="0" anchor="ctr"/>
+          <a:lstStyle/>
+          <a:p>
+            <a:pPr algn="ctr" indent="0" marL="0">
+              <a:buNone/>
+            </a:pPr>
+            <a:r>
+              <a:rPr lang="en-US" sz="1000" i="1" dirty="0">
+                <a:solidFill>
+                  <a:srgbClr val="64748B"/>
+                </a:solidFill>
+              </a:rPr>
+              <a:t>Encontros individuais 1:1 · Exercícios práticos entre os encontros · Apoio de IA para continuidade · Acompanhamento contínuo</a:t>
+            </a:r>
+            <a:endParaRPr lang="en-US" sz="1000" dirty="0"/>
+          </a:p>
+        </p:txBody>
+      </p:sp>
+      <p:sp>
+        <p:nvSpPr>
+          <p:cNvPr id="45" name="Text 43"/>
+          <p:cNvSpPr/>
+          <p:nvPr/>
+        </p:nvSpPr>
+        <p:spPr>
+          <a:xfrm>
+            <a:off x="9814255" y="6355080"/>
+            <a:ext cx="2103120" cy="274320"/>
+          </a:xfrm>
+          <a:prstGeom prst="rect">
+            <a:avLst/>
+          </a:prstGeom>
+          <a:noFill/>
+          <a:ln/>
+        </p:spPr>
+        <p:txBody>
+          <a:bodyPr wrap="square" rtlCol="0" anchor="ctr"/>
+          <a:lstStyle/>
+          <a:p>
+            <a:pPr algn="r" indent="0" marL="0">
+              <a:buNone/>
+            </a:pPr>
+            <a:r>
+              <a:rPr lang="en-US" sz="1000" dirty="0">
+                <a:solidFill>
+                  <a:srgbClr val="94A3B8"/>
+                </a:solidFill>
+              </a:rPr>
+              <a:t>Escala Você · 07</a:t>
+            </a:r>
+            <a:endParaRPr lang="en-US" sz="1000" dirty="0"/>
+          </a:p>
+        </p:txBody>
+      </p:sp>
+    </p:spTree>
+  </p:cSld>
+  <p:clrMapOvr>
+    <a:masterClrMapping/>
+  </p:clrMapOvr>
+</p:sld>
+</file>
+
+<file path=ppt/slides/slide8.xml><?xml version="1.0" encoding="utf-8"?>
+<p:sld xmlns:a="http://schemas.openxmlformats.org/drawingml/2006/main" xmlns:r="http://schemas.openxmlformats.org/officeDocument/2006/relationships" xmlns:p="http://schemas.openxmlformats.org/presentationml/2006/main">
+  <p:cSld name="Slide 8">
+    <p:bg>
+      <p:bgPr>
+        <a:solidFill>
           <a:srgbClr val="F8FAFC"/>
         </a:solidFill>
       </p:bgPr>
@@ -9128,7 +10650,7 @@
                   <a:srgbClr val="2563EB"/>
                 </a:solidFill>
               </a:rPr>
-              <a:t>FORMATO INDIVIDUAL</a:t>
+              <a:t>COMO FUNCIONA</a:t>
             </a:r>
             <a:endParaRPr lang="en-US" sz="1200" dirty="0"/>
           </a:p>
@@ -9164,7 +10686,7 @@
                   <a:srgbClr val="0F172A"/>
                 </a:solidFill>
               </a:rPr>
-              <a:t>Como funciona</a:t>
+              <a:t>Formato em grupo até 3 pessoas</a:t>
             </a:r>
             <a:endParaRPr lang="en-US" sz="2600" dirty="0"/>
           </a:p>
@@ -9200,16 +10722,16 @@
         </p:nvSpPr>
         <p:spPr>
           <a:xfrm>
-            <a:off x="792328" y="1325880"/>
-            <a:ext cx="3383280" cy="640080"/>
+            <a:off x="3992728" y="1252728"/>
+            <a:ext cx="4206240" cy="365760"/>
           </a:xfrm>
           <a:prstGeom prst="roundRect">
             <a:avLst>
-              <a:gd name="adj" fmla="val 17143"/>
+              <a:gd name="adj" fmla="val 50000"/>
             </a:avLst>
           </a:prstGeom>
           <a:solidFill>
-            <a:srgbClr val="1D4ED8"/>
+            <a:srgbClr val="FEF3C7"/>
           </a:solidFill>
           <a:ln/>
         </p:spPr>
@@ -9222,267 +10744,43 @@
         </p:nvSpPr>
         <p:spPr>
           <a:xfrm>
-            <a:off x="975208" y="1399032"/>
-            <a:ext cx="3017520" cy="228600"/>
-          </a:xfrm>
-          <a:prstGeom prst="rect">
-            <a:avLst/>
-          </a:prstGeom>
-          <a:noFill/>
-          <a:ln/>
-        </p:spPr>
-        <p:txBody>
-          <a:bodyPr wrap="square" rtlCol="0" anchor="ctr"/>
-          <a:lstStyle/>
-          <a:p>
-            <a:pPr indent="0" marL="0">
-              <a:buNone/>
-            </a:pPr>
-            <a:r>
-              <a:rPr lang="en-US" sz="950" dirty="0">
-                <a:solidFill>
-                  <a:srgbClr val="BFDBFE"/>
-                </a:solidFill>
-              </a:rPr>
-              <a:t>Duração total</a:t>
-            </a:r>
-            <a:endParaRPr lang="en-US" sz="950" dirty="0"/>
-          </a:p>
-        </p:txBody>
-      </p:sp>
-      <p:sp>
-        <p:nvSpPr>
-          <p:cNvPr id="7" name="Text 5"/>
-          <p:cNvSpPr/>
-          <p:nvPr/>
-        </p:nvSpPr>
-        <p:spPr>
-          <a:xfrm>
-            <a:off x="975208" y="1618488"/>
-            <a:ext cx="3017520" cy="292608"/>
-          </a:xfrm>
-          <a:prstGeom prst="rect">
-            <a:avLst/>
-          </a:prstGeom>
-          <a:noFill/>
-          <a:ln/>
-        </p:spPr>
-        <p:txBody>
-          <a:bodyPr wrap="square" rtlCol="0" anchor="ctr"/>
-          <a:lstStyle/>
-          <a:p>
-            <a:pPr indent="0" marL="0">
-              <a:buNone/>
-            </a:pPr>
-            <a:r>
-              <a:rPr lang="en-US" sz="1500" b="1" dirty="0">
-                <a:solidFill>
-                  <a:srgbClr val="FFFFFF"/>
-                </a:solidFill>
-              </a:rPr>
-              <a:t>8 semanas</a:t>
-            </a:r>
-            <a:endParaRPr lang="en-US" sz="1500" dirty="0"/>
-          </a:p>
-        </p:txBody>
-      </p:sp>
-      <p:sp>
-        <p:nvSpPr>
-          <p:cNvPr id="8" name="Shape 6"/>
-          <p:cNvSpPr/>
-          <p:nvPr/>
-        </p:nvSpPr>
-        <p:spPr>
-          <a:xfrm>
-            <a:off x="4404208" y="1325880"/>
-            <a:ext cx="3383280" cy="640080"/>
-          </a:xfrm>
-          <a:prstGeom prst="roundRect">
-            <a:avLst>
-              <a:gd name="adj" fmla="val 17143"/>
-            </a:avLst>
-          </a:prstGeom>
-          <a:solidFill>
-            <a:srgbClr val="1D4ED8"/>
-          </a:solidFill>
-          <a:ln/>
-        </p:spPr>
-      </p:sp>
-      <p:sp>
-        <p:nvSpPr>
-          <p:cNvPr id="9" name="Text 7"/>
-          <p:cNvSpPr/>
-          <p:nvPr/>
-        </p:nvSpPr>
-        <p:spPr>
-          <a:xfrm>
-            <a:off x="4587088" y="1399032"/>
-            <a:ext cx="3017520" cy="228600"/>
-          </a:xfrm>
-          <a:prstGeom prst="rect">
-            <a:avLst/>
-          </a:prstGeom>
-          <a:noFill/>
-          <a:ln/>
-        </p:spPr>
-        <p:txBody>
-          <a:bodyPr wrap="square" rtlCol="0" anchor="ctr"/>
-          <a:lstStyle/>
-          <a:p>
-            <a:pPr indent="0" marL="0">
-              <a:buNone/>
-            </a:pPr>
-            <a:r>
-              <a:rPr lang="en-US" sz="950" dirty="0">
-                <a:solidFill>
-                  <a:srgbClr val="BFDBFE"/>
-                </a:solidFill>
-              </a:rPr>
-              <a:t>Total de encontros</a:t>
-            </a:r>
-            <a:endParaRPr lang="en-US" sz="950" dirty="0"/>
-          </a:p>
-        </p:txBody>
-      </p:sp>
-      <p:sp>
-        <p:nvSpPr>
-          <p:cNvPr id="10" name="Text 8"/>
-          <p:cNvSpPr/>
-          <p:nvPr/>
-        </p:nvSpPr>
-        <p:spPr>
-          <a:xfrm>
-            <a:off x="4587088" y="1618488"/>
-            <a:ext cx="3017520" cy="292608"/>
-          </a:xfrm>
-          <a:prstGeom prst="rect">
-            <a:avLst/>
-          </a:prstGeom>
-          <a:noFill/>
-          <a:ln/>
-        </p:spPr>
-        <p:txBody>
-          <a:bodyPr wrap="square" rtlCol="0" anchor="ctr"/>
-          <a:lstStyle/>
-          <a:p>
-            <a:pPr indent="0" marL="0">
-              <a:buNone/>
-            </a:pPr>
-            <a:r>
-              <a:rPr lang="en-US" sz="1500" b="1" dirty="0">
-                <a:solidFill>
-                  <a:srgbClr val="FFFFFF"/>
-                </a:solidFill>
-              </a:rPr>
-              <a:t>7 encontros</a:t>
-            </a:r>
-            <a:endParaRPr lang="en-US" sz="1500" dirty="0"/>
-          </a:p>
-        </p:txBody>
-      </p:sp>
-      <p:sp>
-        <p:nvSpPr>
-          <p:cNvPr id="11" name="Shape 9"/>
-          <p:cNvSpPr/>
-          <p:nvPr/>
-        </p:nvSpPr>
-        <p:spPr>
-          <a:xfrm>
-            <a:off x="8016088" y="1325880"/>
-            <a:ext cx="3383280" cy="640080"/>
-          </a:xfrm>
-          <a:prstGeom prst="roundRect">
-            <a:avLst>
-              <a:gd name="adj" fmla="val 17143"/>
-            </a:avLst>
-          </a:prstGeom>
-          <a:solidFill>
-            <a:srgbClr val="1D4ED8"/>
-          </a:solidFill>
-          <a:ln/>
-        </p:spPr>
-      </p:sp>
-      <p:sp>
-        <p:nvSpPr>
-          <p:cNvPr id="12" name="Text 10"/>
-          <p:cNvSpPr/>
-          <p:nvPr/>
-        </p:nvSpPr>
-        <p:spPr>
-          <a:xfrm>
-            <a:off x="8198968" y="1399032"/>
-            <a:ext cx="3017520" cy="228600"/>
-          </a:xfrm>
-          <a:prstGeom prst="rect">
-            <a:avLst/>
-          </a:prstGeom>
-          <a:noFill/>
-          <a:ln/>
-        </p:spPr>
-        <p:txBody>
-          <a:bodyPr wrap="square" rtlCol="0" anchor="ctr"/>
-          <a:lstStyle/>
-          <a:p>
-            <a:pPr indent="0" marL="0">
-              <a:buNone/>
-            </a:pPr>
-            <a:r>
-              <a:rPr lang="en-US" sz="950" dirty="0">
-                <a:solidFill>
-                  <a:srgbClr val="BFDBFE"/>
-                </a:solidFill>
-              </a:rPr>
-              <a:t>Duração dos encontros</a:t>
-            </a:r>
-            <a:endParaRPr lang="en-US" sz="950" dirty="0"/>
-          </a:p>
-        </p:txBody>
-      </p:sp>
-      <p:sp>
-        <p:nvSpPr>
-          <p:cNvPr id="13" name="Text 11"/>
-          <p:cNvSpPr/>
-          <p:nvPr/>
-        </p:nvSpPr>
-        <p:spPr>
-          <a:xfrm>
-            <a:off x="8198968" y="1618488"/>
-            <a:ext cx="3017520" cy="292608"/>
-          </a:xfrm>
-          <a:prstGeom prst="rect">
-            <a:avLst/>
-          </a:prstGeom>
-          <a:noFill/>
-          <a:ln/>
-        </p:spPr>
-        <p:txBody>
-          <a:bodyPr wrap="square" rtlCol="0" anchor="ctr"/>
-          <a:lstStyle/>
-          <a:p>
-            <a:pPr indent="0" marL="0">
-              <a:buNone/>
-            </a:pPr>
-            <a:r>
-              <a:rPr lang="en-US" sz="1500" b="1" dirty="0">
-                <a:solidFill>
-                  <a:srgbClr val="FFFFFF"/>
-                </a:solidFill>
-              </a:rPr>
-              <a:t>1,5h cada</a:t>
-            </a:r>
-            <a:endParaRPr lang="en-US" sz="1500" dirty="0"/>
-          </a:p>
-        </p:txBody>
-      </p:sp>
-      <p:sp>
-        <p:nvSpPr>
-          <p:cNvPr id="14" name="Shape 12"/>
-          <p:cNvSpPr/>
-          <p:nvPr/>
-        </p:nvSpPr>
-        <p:spPr>
-          <a:xfrm>
-            <a:off x="792328" y="2148840"/>
+            <a:off x="3992728" y="1252728"/>
+            <a:ext cx="4206240" cy="365760"/>
+          </a:xfrm>
+          <a:prstGeom prst="rect">
+            <a:avLst/>
+          </a:prstGeom>
+          <a:noFill/>
+          <a:ln/>
+        </p:spPr>
+        <p:txBody>
+          <a:bodyPr wrap="square" rtlCol="0" anchor="ctr"/>
+          <a:lstStyle/>
+          <a:p>
+            <a:pPr algn="ctr" indent="0" marL="0">
+              <a:buNone/>
+            </a:pPr>
+            <a:r>
+              <a:rPr lang="en-US" sz="1100" b="1" dirty="0">
+                <a:solidFill>
+                  <a:srgbClr val="B45309"/>
+                </a:solidFill>
+              </a:rPr>
+              <a:t>🎁  Proposta especial para participantes do evento "Da ideia à Ação"</a:t>
+            </a:r>
+            <a:endParaRPr lang="en-US" sz="1100" dirty="0"/>
+          </a:p>
+        </p:txBody>
+      </p:sp>
+      <p:sp>
+        <p:nvSpPr>
+          <p:cNvPr id="7" name="Shape 5"/>
+          <p:cNvSpPr/>
+          <p:nvPr/>
+        </p:nvSpPr>
+        <p:spPr>
+          <a:xfrm>
+            <a:off x="792328" y="1755648"/>
             <a:ext cx="3383280" cy="3154680"/>
           </a:xfrm>
           <a:prstGeom prst="roundRect">
@@ -9510,13 +10808,13 @@
       </p:sp>
       <p:sp>
         <p:nvSpPr>
-          <p:cNvPr id="15" name="Shape 13"/>
-          <p:cNvSpPr/>
-          <p:nvPr/>
-        </p:nvSpPr>
-        <p:spPr>
-          <a:xfrm>
-            <a:off x="1020928" y="2377440"/>
+          <p:cNvPr id="8" name="Shape 6"/>
+          <p:cNvSpPr/>
+          <p:nvPr/>
+        </p:nvSpPr>
+        <p:spPr>
+          <a:xfrm>
+            <a:off x="1020928" y="1984248"/>
             <a:ext cx="502920" cy="502920"/>
           </a:xfrm>
           <a:prstGeom prst="roundRect">
@@ -9532,13 +10830,13 @@
       </p:sp>
       <p:sp>
         <p:nvSpPr>
-          <p:cNvPr id="16" name="Text 14"/>
-          <p:cNvSpPr/>
-          <p:nvPr/>
-        </p:nvSpPr>
-        <p:spPr>
-          <a:xfrm>
-            <a:off x="1020928" y="2377440"/>
+          <p:cNvPr id="9" name="Text 7"/>
+          <p:cNvSpPr/>
+          <p:nvPr/>
+        </p:nvSpPr>
+        <p:spPr>
+          <a:xfrm>
+            <a:off x="1020928" y="1984248"/>
             <a:ext cx="502920" cy="502920"/>
           </a:xfrm>
           <a:prstGeom prst="rect">
@@ -9568,13 +10866,13 @@
       </p:sp>
       <p:sp>
         <p:nvSpPr>
-          <p:cNvPr id="17" name="Text 15"/>
-          <p:cNvSpPr/>
-          <p:nvPr/>
-        </p:nvSpPr>
-        <p:spPr>
-          <a:xfrm>
-            <a:off x="1020928" y="2971800"/>
+          <p:cNvPr id="10" name="Text 8"/>
+          <p:cNvSpPr/>
+          <p:nvPr/>
+        </p:nvSpPr>
+        <p:spPr>
+          <a:xfrm>
+            <a:off x="1020928" y="2578608"/>
             <a:ext cx="2926080" cy="228600"/>
           </a:xfrm>
           <a:prstGeom prst="rect">
@@ -9604,13 +10902,13 @@
       </p:sp>
       <p:sp>
         <p:nvSpPr>
-          <p:cNvPr id="18" name="Text 16"/>
-          <p:cNvSpPr/>
-          <p:nvPr/>
-        </p:nvSpPr>
-        <p:spPr>
-          <a:xfrm>
-            <a:off x="1020928" y="3200400"/>
+          <p:cNvPr id="11" name="Text 9"/>
+          <p:cNvSpPr/>
+          <p:nvPr/>
+        </p:nvSpPr>
+        <p:spPr>
+          <a:xfrm>
+            <a:off x="1020928" y="2807208"/>
             <a:ext cx="2926080" cy="640080"/>
           </a:xfrm>
           <a:prstGeom prst="rect">
@@ -9632,7 +10930,7 @@
                   <a:srgbClr val="0F172A"/>
                 </a:solidFill>
               </a:rPr>
-              <a:t>Quem sou como empreendedor?</a:t>
+              <a:t>Quem sou como empreendedor? *</a:t>
             </a:r>
             <a:endParaRPr lang="en-US" sz="1450" dirty="0"/>
           </a:p>
@@ -9640,13 +10938,13 @@
       </p:sp>
       <p:sp>
         <p:nvSpPr>
-          <p:cNvPr id="19" name="Text 17"/>
-          <p:cNvSpPr/>
-          <p:nvPr/>
-        </p:nvSpPr>
-        <p:spPr>
-          <a:xfrm>
-            <a:off x="1020928" y="3840480"/>
+          <p:cNvPr id="12" name="Text 10"/>
+          <p:cNvSpPr/>
+          <p:nvPr/>
+        </p:nvSpPr>
+        <p:spPr>
+          <a:xfrm>
+            <a:off x="1020928" y="3447288"/>
             <a:ext cx="2926080" cy="685800"/>
           </a:xfrm>
           <a:prstGeom prst="rect">
@@ -9672,7 +10970,7 @@
                   <a:srgbClr val="475569"/>
                 </a:solidFill>
               </a:rPr>
-              <a:t>4 encontros · 3 assessments</a:t>
+              <a:t>4 encontros</a:t>
             </a:r>
             <a:endParaRPr lang="en-US" sz="1050" dirty="0"/>
           </a:p>
@@ -9698,13 +10996,13 @@
       </p:sp>
       <p:sp>
         <p:nvSpPr>
-          <p:cNvPr id="20" name="Shape 18"/>
-          <p:cNvSpPr/>
-          <p:nvPr/>
-        </p:nvSpPr>
-        <p:spPr>
-          <a:xfrm>
-            <a:off x="1020928" y="4389120"/>
+          <p:cNvPr id="13" name="Shape 11"/>
+          <p:cNvSpPr/>
+          <p:nvPr/>
+        </p:nvSpPr>
+        <p:spPr>
+          <a:xfrm>
+            <a:off x="1020928" y="3995928"/>
             <a:ext cx="2926080" cy="731520"/>
           </a:xfrm>
           <a:prstGeom prst="roundRect">
@@ -9720,13 +11018,13 @@
       </p:sp>
       <p:sp>
         <p:nvSpPr>
-          <p:cNvPr id="21" name="Text 19"/>
-          <p:cNvSpPr/>
-          <p:nvPr/>
-        </p:nvSpPr>
-        <p:spPr>
-          <a:xfrm>
-            <a:off x="1158088" y="4462272"/>
+          <p:cNvPr id="14" name="Text 12"/>
+          <p:cNvSpPr/>
+          <p:nvPr/>
+        </p:nvSpPr>
+        <p:spPr>
+          <a:xfrm>
+            <a:off x="1158088" y="4069080"/>
             <a:ext cx="2651760" cy="201168"/>
           </a:xfrm>
           <a:prstGeom prst="rect">
@@ -9748,7 +11046,7 @@
                   <a:srgbClr val="64748B"/>
                 </a:solidFill>
               </a:rPr>
-              <a:t>Investimento</a:t>
+              <a:t>Investimento por pessoa</a:t>
             </a:r>
             <a:endParaRPr lang="en-US" sz="900" dirty="0"/>
           </a:p>
@@ -9756,13 +11054,13 @@
       </p:sp>
       <p:sp>
         <p:nvSpPr>
-          <p:cNvPr id="22" name="Text 20"/>
-          <p:cNvSpPr/>
-          <p:nvPr/>
-        </p:nvSpPr>
-        <p:spPr>
-          <a:xfrm>
-            <a:off x="1158088" y="4645152"/>
+          <p:cNvPr id="15" name="Text 13"/>
+          <p:cNvSpPr/>
+          <p:nvPr/>
+        </p:nvSpPr>
+        <p:spPr>
+          <a:xfrm>
+            <a:off x="1158088" y="4251960"/>
             <a:ext cx="2651760" cy="365760"/>
           </a:xfrm>
           <a:prstGeom prst="rect">
@@ -9784,7 +11082,7 @@
                   <a:srgbClr val="1D4ED8"/>
                 </a:solidFill>
               </a:rPr>
-              <a:t>R$ 3.800</a:t>
+              <a:t>R$ 1.350</a:t>
             </a:r>
             <a:endParaRPr lang="en-US" sz="2000" dirty="0"/>
           </a:p>
@@ -9792,13 +11090,13 @@
       </p:sp>
       <p:sp>
         <p:nvSpPr>
-          <p:cNvPr id="23" name="Shape 21"/>
-          <p:cNvSpPr/>
-          <p:nvPr/>
-        </p:nvSpPr>
-        <p:spPr>
-          <a:xfrm>
-            <a:off x="4404208" y="2148840"/>
+          <p:cNvPr id="16" name="Shape 14"/>
+          <p:cNvSpPr/>
+          <p:nvPr/>
+        </p:nvSpPr>
+        <p:spPr>
+          <a:xfrm>
+            <a:off x="4404208" y="1755648"/>
             <a:ext cx="3383280" cy="3154680"/>
           </a:xfrm>
           <a:prstGeom prst="roundRect">
@@ -9826,13 +11124,13 @@
       </p:sp>
       <p:sp>
         <p:nvSpPr>
-          <p:cNvPr id="24" name="Shape 22"/>
-          <p:cNvSpPr/>
-          <p:nvPr/>
-        </p:nvSpPr>
-        <p:spPr>
-          <a:xfrm>
-            <a:off x="4632808" y="2377440"/>
+          <p:cNvPr id="17" name="Shape 15"/>
+          <p:cNvSpPr/>
+          <p:nvPr/>
+        </p:nvSpPr>
+        <p:spPr>
+          <a:xfrm>
+            <a:off x="4632808" y="1984248"/>
             <a:ext cx="502920" cy="502920"/>
           </a:xfrm>
           <a:prstGeom prst="roundRect">
@@ -9848,13 +11146,13 @@
       </p:sp>
       <p:sp>
         <p:nvSpPr>
-          <p:cNvPr id="25" name="Text 23"/>
-          <p:cNvSpPr/>
-          <p:nvPr/>
-        </p:nvSpPr>
-        <p:spPr>
-          <a:xfrm>
-            <a:off x="4632808" y="2377440"/>
+          <p:cNvPr id="18" name="Text 16"/>
+          <p:cNvSpPr/>
+          <p:nvPr/>
+        </p:nvSpPr>
+        <p:spPr>
+          <a:xfrm>
+            <a:off x="4632808" y="1984248"/>
             <a:ext cx="502920" cy="502920"/>
           </a:xfrm>
           <a:prstGeom prst="rect">
@@ -9884,13 +11182,13 @@
       </p:sp>
       <p:sp>
         <p:nvSpPr>
-          <p:cNvPr id="26" name="Text 24"/>
-          <p:cNvSpPr/>
-          <p:nvPr/>
-        </p:nvSpPr>
-        <p:spPr>
-          <a:xfrm>
-            <a:off x="4632808" y="2971800"/>
+          <p:cNvPr id="19" name="Text 17"/>
+          <p:cNvSpPr/>
+          <p:nvPr/>
+        </p:nvSpPr>
+        <p:spPr>
+          <a:xfrm>
+            <a:off x="4632808" y="2578608"/>
             <a:ext cx="2926080" cy="228600"/>
           </a:xfrm>
           <a:prstGeom prst="rect">
@@ -9920,13 +11218,13 @@
       </p:sp>
       <p:sp>
         <p:nvSpPr>
-          <p:cNvPr id="27" name="Text 25"/>
-          <p:cNvSpPr/>
-          <p:nvPr/>
-        </p:nvSpPr>
-        <p:spPr>
-          <a:xfrm>
-            <a:off x="4632808" y="3200400"/>
+          <p:cNvPr id="20" name="Text 18"/>
+          <p:cNvSpPr/>
+          <p:nvPr/>
+        </p:nvSpPr>
+        <p:spPr>
+          <a:xfrm>
+            <a:off x="4632808" y="2807208"/>
             <a:ext cx="2926080" cy="640080"/>
           </a:xfrm>
           <a:prstGeom prst="rect">
@@ -9956,13 +11254,13 @@
       </p:sp>
       <p:sp>
         <p:nvSpPr>
-          <p:cNvPr id="28" name="Text 26"/>
-          <p:cNvSpPr/>
-          <p:nvPr/>
-        </p:nvSpPr>
-        <p:spPr>
-          <a:xfrm>
-            <a:off x="4632808" y="3840480"/>
+          <p:cNvPr id="21" name="Text 19"/>
+          <p:cNvSpPr/>
+          <p:nvPr/>
+        </p:nvSpPr>
+        <p:spPr>
+          <a:xfrm>
+            <a:off x="4632808" y="3447288"/>
             <a:ext cx="2926080" cy="685800"/>
           </a:xfrm>
           <a:prstGeom prst="rect">
@@ -10014,13 +11312,13 @@
       </p:sp>
       <p:sp>
         <p:nvSpPr>
-          <p:cNvPr id="29" name="Shape 27"/>
-          <p:cNvSpPr/>
-          <p:nvPr/>
-        </p:nvSpPr>
-        <p:spPr>
-          <a:xfrm>
-            <a:off x="4632808" y="4389120"/>
+          <p:cNvPr id="22" name="Shape 20"/>
+          <p:cNvSpPr/>
+          <p:nvPr/>
+        </p:nvSpPr>
+        <p:spPr>
+          <a:xfrm>
+            <a:off x="4632808" y="3995928"/>
             <a:ext cx="2926080" cy="731520"/>
           </a:xfrm>
           <a:prstGeom prst="roundRect">
@@ -10036,13 +11334,13 @@
       </p:sp>
       <p:sp>
         <p:nvSpPr>
-          <p:cNvPr id="30" name="Text 28"/>
-          <p:cNvSpPr/>
-          <p:nvPr/>
-        </p:nvSpPr>
-        <p:spPr>
-          <a:xfrm>
-            <a:off x="4769968" y="4462272"/>
+          <p:cNvPr id="23" name="Text 21"/>
+          <p:cNvSpPr/>
+          <p:nvPr/>
+        </p:nvSpPr>
+        <p:spPr>
+          <a:xfrm>
+            <a:off x="4769968" y="4069080"/>
             <a:ext cx="2651760" cy="201168"/>
           </a:xfrm>
           <a:prstGeom prst="rect">
@@ -10064,7 +11362,7 @@
                   <a:srgbClr val="64748B"/>
                 </a:solidFill>
               </a:rPr>
-              <a:t>Investimento</a:t>
+              <a:t>Investimento por pessoa</a:t>
             </a:r>
             <a:endParaRPr lang="en-US" sz="900" dirty="0"/>
           </a:p>
@@ -10072,13 +11370,13 @@
       </p:sp>
       <p:sp>
         <p:nvSpPr>
-          <p:cNvPr id="31" name="Text 29"/>
-          <p:cNvSpPr/>
-          <p:nvPr/>
-        </p:nvSpPr>
-        <p:spPr>
-          <a:xfrm>
-            <a:off x="4769968" y="4645152"/>
+          <p:cNvPr id="24" name="Text 22"/>
+          <p:cNvSpPr/>
+          <p:nvPr/>
+        </p:nvSpPr>
+        <p:spPr>
+          <a:xfrm>
+            <a:off x="4769968" y="4251960"/>
             <a:ext cx="2651760" cy="365760"/>
           </a:xfrm>
           <a:prstGeom prst="rect">
@@ -10100,7 +11398,7 @@
                   <a:srgbClr val="4338CA"/>
                 </a:solidFill>
               </a:rPr>
-              <a:t>R$ 2.800</a:t>
+              <a:t>R$ 1.000</a:t>
             </a:r>
             <a:endParaRPr lang="en-US" sz="2000" dirty="0"/>
           </a:p>
@@ -10108,13 +11406,13 @@
       </p:sp>
       <p:sp>
         <p:nvSpPr>
-          <p:cNvPr id="32" name="Shape 30"/>
-          <p:cNvSpPr/>
-          <p:nvPr/>
-        </p:nvSpPr>
-        <p:spPr>
-          <a:xfrm>
-            <a:off x="8016088" y="2148840"/>
+          <p:cNvPr id="25" name="Shape 23"/>
+          <p:cNvSpPr/>
+          <p:nvPr/>
+        </p:nvSpPr>
+        <p:spPr>
+          <a:xfrm>
+            <a:off x="8016088" y="1755648"/>
             <a:ext cx="3383280" cy="3154680"/>
           </a:xfrm>
           <a:prstGeom prst="roundRect">
@@ -10142,13 +11440,13 @@
       </p:sp>
       <p:sp>
         <p:nvSpPr>
-          <p:cNvPr id="33" name="Shape 31"/>
-          <p:cNvSpPr/>
-          <p:nvPr/>
-        </p:nvSpPr>
-        <p:spPr>
-          <a:xfrm>
-            <a:off x="9707728" y="1984248"/>
+          <p:cNvPr id="26" name="Shape 24"/>
+          <p:cNvSpPr/>
+          <p:nvPr/>
+        </p:nvSpPr>
+        <p:spPr>
+          <a:xfrm>
+            <a:off x="9707728" y="1591056"/>
             <a:ext cx="1554480" cy="329184"/>
           </a:xfrm>
           <a:prstGeom prst="roundRect">
@@ -10164,13 +11462,13 @@
       </p:sp>
       <p:sp>
         <p:nvSpPr>
-          <p:cNvPr id="34" name="Text 32"/>
-          <p:cNvSpPr/>
-          <p:nvPr/>
-        </p:nvSpPr>
-        <p:spPr>
-          <a:xfrm>
-            <a:off x="9707728" y="1984248"/>
+          <p:cNvPr id="27" name="Text 25"/>
+          <p:cNvSpPr/>
+          <p:nvPr/>
+        </p:nvSpPr>
+        <p:spPr>
+          <a:xfrm>
+            <a:off x="9707728" y="1591056"/>
             <a:ext cx="1554480" cy="329184"/>
           </a:xfrm>
           <a:prstGeom prst="rect">
@@ -10200,13 +11498,13 @@
       </p:sp>
       <p:sp>
         <p:nvSpPr>
-          <p:cNvPr id="35" name="Shape 33"/>
-          <p:cNvSpPr/>
-          <p:nvPr/>
-        </p:nvSpPr>
-        <p:spPr>
-          <a:xfrm>
-            <a:off x="8244688" y="2377440"/>
+          <p:cNvPr id="28" name="Shape 26"/>
+          <p:cNvSpPr/>
+          <p:nvPr/>
+        </p:nvSpPr>
+        <p:spPr>
+          <a:xfrm>
+            <a:off x="8244688" y="1984248"/>
             <a:ext cx="502920" cy="502920"/>
           </a:xfrm>
           <a:prstGeom prst="roundRect">
@@ -10222,13 +11520,13 @@
       </p:sp>
       <p:sp>
         <p:nvSpPr>
-          <p:cNvPr id="36" name="Text 34"/>
-          <p:cNvSpPr/>
-          <p:nvPr/>
-        </p:nvSpPr>
-        <p:spPr>
-          <a:xfrm>
-            <a:off x="8244688" y="2377440"/>
+          <p:cNvPr id="29" name="Text 27"/>
+          <p:cNvSpPr/>
+          <p:nvPr/>
+        </p:nvSpPr>
+        <p:spPr>
+          <a:xfrm>
+            <a:off x="8244688" y="1984248"/>
             <a:ext cx="502920" cy="502920"/>
           </a:xfrm>
           <a:prstGeom prst="rect">
@@ -10258,13 +11556,13 @@
       </p:sp>
       <p:sp>
         <p:nvSpPr>
-          <p:cNvPr id="37" name="Text 35"/>
-          <p:cNvSpPr/>
-          <p:nvPr/>
-        </p:nvSpPr>
-        <p:spPr>
-          <a:xfrm>
-            <a:off x="8244688" y="2971800"/>
+          <p:cNvPr id="30" name="Text 28"/>
+          <p:cNvSpPr/>
+          <p:nvPr/>
+        </p:nvSpPr>
+        <p:spPr>
+          <a:xfrm>
+            <a:off x="8244688" y="2578608"/>
             <a:ext cx="2926080" cy="228600"/>
           </a:xfrm>
           <a:prstGeom prst="rect">
@@ -10294,13 +11592,13 @@
       </p:sp>
       <p:sp>
         <p:nvSpPr>
-          <p:cNvPr id="38" name="Text 36"/>
-          <p:cNvSpPr/>
-          <p:nvPr/>
-        </p:nvSpPr>
-        <p:spPr>
-          <a:xfrm>
-            <a:off x="8244688" y="3200400"/>
+          <p:cNvPr id="31" name="Text 29"/>
+          <p:cNvSpPr/>
+          <p:nvPr/>
+        </p:nvSpPr>
+        <p:spPr>
+          <a:xfrm>
+            <a:off x="8244688" y="2807208"/>
             <a:ext cx="2926080" cy="640080"/>
           </a:xfrm>
           <a:prstGeom prst="rect">
@@ -10322,7 +11620,7 @@
                   <a:srgbClr val="0F172A"/>
                 </a:solidFill>
               </a:rPr>
-              <a:t>Programa Completo</a:t>
+              <a:t>Programa Completo *</a:t>
             </a:r>
             <a:endParaRPr lang="en-US" sz="1450" dirty="0"/>
           </a:p>
@@ -10330,13 +11628,13 @@
       </p:sp>
       <p:sp>
         <p:nvSpPr>
-          <p:cNvPr id="39" name="Text 37"/>
-          <p:cNvSpPr/>
-          <p:nvPr/>
-        </p:nvSpPr>
-        <p:spPr>
-          <a:xfrm>
-            <a:off x="8244688" y="3840480"/>
+          <p:cNvPr id="32" name="Text 30"/>
+          <p:cNvSpPr/>
+          <p:nvPr/>
+        </p:nvSpPr>
+        <p:spPr>
+          <a:xfrm>
+            <a:off x="8244688" y="3447288"/>
             <a:ext cx="2926080" cy="685800"/>
           </a:xfrm>
           <a:prstGeom prst="rect">
@@ -10388,13 +11686,13 @@
       </p:sp>
       <p:sp>
         <p:nvSpPr>
-          <p:cNvPr id="40" name="Shape 38"/>
-          <p:cNvSpPr/>
-          <p:nvPr/>
-        </p:nvSpPr>
-        <p:spPr>
-          <a:xfrm>
-            <a:off x="8244688" y="4389120"/>
+          <p:cNvPr id="33" name="Shape 31"/>
+          <p:cNvSpPr/>
+          <p:nvPr/>
+        </p:nvSpPr>
+        <p:spPr>
+          <a:xfrm>
+            <a:off x="8244688" y="3995928"/>
             <a:ext cx="2926080" cy="731520"/>
           </a:xfrm>
           <a:prstGeom prst="roundRect">
@@ -10410,13 +11708,13 @@
       </p:sp>
       <p:sp>
         <p:nvSpPr>
-          <p:cNvPr id="41" name="Text 39"/>
-          <p:cNvSpPr/>
-          <p:nvPr/>
-        </p:nvSpPr>
-        <p:spPr>
-          <a:xfrm>
-            <a:off x="8381848" y="4462272"/>
+          <p:cNvPr id="34" name="Text 32"/>
+          <p:cNvSpPr/>
+          <p:nvPr/>
+        </p:nvSpPr>
+        <p:spPr>
+          <a:xfrm>
+            <a:off x="8381848" y="4069080"/>
             <a:ext cx="2651760" cy="201168"/>
           </a:xfrm>
           <a:prstGeom prst="rect">
@@ -10438,7 +11736,7 @@
                   <a:srgbClr val="64748B"/>
                 </a:solidFill>
               </a:rPr>
-              <a:t>Investimento</a:t>
+              <a:t>Investimento por pessoa</a:t>
             </a:r>
             <a:endParaRPr lang="en-US" sz="900" dirty="0"/>
           </a:p>
@@ -10446,13 +11744,13 @@
       </p:sp>
       <p:sp>
         <p:nvSpPr>
-          <p:cNvPr id="42" name="Text 40"/>
-          <p:cNvSpPr/>
-          <p:nvPr/>
-        </p:nvSpPr>
-        <p:spPr>
-          <a:xfrm>
-            <a:off x="8381848" y="4645152"/>
+          <p:cNvPr id="35" name="Text 33"/>
+          <p:cNvSpPr/>
+          <p:nvPr/>
+        </p:nvSpPr>
+        <p:spPr>
+          <a:xfrm>
+            <a:off x="8381848" y="4251960"/>
             <a:ext cx="2651760" cy="365760"/>
           </a:xfrm>
           <a:prstGeom prst="rect">
@@ -10474,7 +11772,7 @@
                   <a:srgbClr val="1D4ED8"/>
                 </a:solidFill>
               </a:rPr>
-              <a:t>R$ 6.000</a:t>
+              <a:t>R$ 2.000</a:t>
             </a:r>
             <a:endParaRPr lang="en-US" sz="2000" dirty="0"/>
           </a:p>
@@ -10482,13 +11780,13 @@
       </p:sp>
       <p:sp>
         <p:nvSpPr>
-          <p:cNvPr id="43" name="Text 41"/>
-          <p:cNvSpPr/>
-          <p:nvPr/>
-        </p:nvSpPr>
-        <p:spPr>
-          <a:xfrm>
-            <a:off x="8381848" y="5010912"/>
+          <p:cNvPr id="36" name="Text 34"/>
+          <p:cNvSpPr/>
+          <p:nvPr/>
+        </p:nvSpPr>
+        <p:spPr>
+          <a:xfrm>
+            <a:off x="8381848" y="4617720"/>
             <a:ext cx="2651760" cy="228600"/>
           </a:xfrm>
           <a:prstGeom prst="rect">
@@ -10510,7 +11808,7 @@
                   <a:srgbClr val="059669"/>
                 </a:solidFill>
               </a:rPr>
-              <a:t>✨ Economia de R$ 600</a:t>
+              <a:t>✨ Economia de R$ 350</a:t>
             </a:r>
             <a:endParaRPr lang="en-US" sz="900" dirty="0"/>
           </a:p>
@@ -10518,14 +11816,14 @@
       </p:sp>
       <p:sp>
         <p:nvSpPr>
-          <p:cNvPr id="44" name="Text 42"/>
-          <p:cNvSpPr/>
-          <p:nvPr/>
-        </p:nvSpPr>
-        <p:spPr>
-          <a:xfrm>
-            <a:off x="792328" y="5440680"/>
-            <a:ext cx="10607040" cy="274320"/>
+          <p:cNvPr id="37" name="Text 35"/>
+          <p:cNvSpPr/>
+          <p:nvPr/>
+        </p:nvSpPr>
+        <p:spPr>
+          <a:xfrm>
+            <a:off x="792328" y="5047488"/>
+            <a:ext cx="10607040" cy="365760"/>
           </a:xfrm>
           <a:prstGeom prst="rect">
             <a:avLst/>
@@ -10546,7 +11844,7 @@
                   <a:srgbClr val="64748B"/>
                 </a:solidFill>
               </a:rPr>
-              <a:t>Encontros individuais 1:1 · Exercícios práticos entre os encontros · Apoio de IA para continuidade · Acompanhamento contínuo</a:t>
+              <a:t>* No formato em grupo, o Módulo 1 não prevê a realização do assessment individual Gallup StrengthsFinder.</a:t>
             </a:r>
             <a:endParaRPr lang="en-US" sz="1000" dirty="0"/>
           </a:p>
@@ -10554,1247 +11852,7 @@
       </p:sp>
       <p:sp>
         <p:nvSpPr>
-          <p:cNvPr id="45" name="Text 43"/>
-          <p:cNvSpPr/>
-          <p:nvPr/>
-        </p:nvSpPr>
-        <p:spPr>
-          <a:xfrm>
-            <a:off x="9814255" y="6355080"/>
-            <a:ext cx="2103120" cy="274320"/>
-          </a:xfrm>
-          <a:prstGeom prst="rect">
-            <a:avLst/>
-          </a:prstGeom>
-          <a:noFill/>
-          <a:ln/>
-        </p:spPr>
-        <p:txBody>
-          <a:bodyPr wrap="square" rtlCol="0" anchor="ctr"/>
-          <a:lstStyle/>
-          <a:p>
-            <a:pPr algn="r" indent="0" marL="0">
-              <a:buNone/>
-            </a:pPr>
-            <a:r>
-              <a:rPr lang="en-US" sz="1000" dirty="0">
-                <a:solidFill>
-                  <a:srgbClr val="94A3B8"/>
-                </a:solidFill>
-              </a:rPr>
-              <a:t>Escala Você · 07</a:t>
-            </a:r>
-            <a:endParaRPr lang="en-US" sz="1000" dirty="0"/>
-          </a:p>
-        </p:txBody>
-      </p:sp>
-    </p:spTree>
-  </p:cSld>
-  <p:clrMapOvr>
-    <a:masterClrMapping/>
-  </p:clrMapOvr>
-</p:sld>
-</file>
-
-<file path=ppt/slides/slide8.xml><?xml version="1.0" encoding="utf-8"?>
-<p:sld xmlns:a="http://schemas.openxmlformats.org/drawingml/2006/main" xmlns:r="http://schemas.openxmlformats.org/officeDocument/2006/relationships" xmlns:p="http://schemas.openxmlformats.org/presentationml/2006/main">
-  <p:cSld name="Slide 8">
-    <p:bg>
-      <p:bgPr>
-        <a:solidFill>
-          <a:srgbClr val="FFFFFF"/>
-        </a:solidFill>
-      </p:bgPr>
-    </p:bg>
-    <p:spTree>
-      <p:nvGrpSpPr>
-        <p:cNvPr id="1" name=""/>
-        <p:cNvGrpSpPr/>
-        <p:nvPr/>
-      </p:nvGrpSpPr>
-      <p:grpSpPr>
-        <a:xfrm>
-          <a:off x="0" y="0"/>
-          <a:ext cx="0" cy="0"/>
-          <a:chOff x="0" y="0"/>
-          <a:chExt cx="0" cy="0"/>
-        </a:xfrm>
-      </p:grpSpPr>
-      <p:sp>
-        <p:nvSpPr>
-          <p:cNvPr id="2" name="Text 0"/>
-          <p:cNvSpPr/>
-          <p:nvPr/>
-        </p:nvSpPr>
-        <p:spPr>
-          <a:xfrm>
-            <a:off x="0" y="274320"/>
-            <a:ext cx="12191695" cy="274320"/>
-          </a:xfrm>
-          <a:prstGeom prst="rect">
-            <a:avLst/>
-          </a:prstGeom>
-          <a:noFill/>
-          <a:ln/>
-        </p:spPr>
-        <p:txBody>
-          <a:bodyPr wrap="square" rtlCol="0" anchor="ctr"/>
-          <a:lstStyle/>
-          <a:p>
-            <a:pPr algn="ctr" indent="0" marL="0">
-              <a:buNone/>
-            </a:pPr>
-            <a:r>
-              <a:rPr lang="en-US" sz="1200" b="1" spc="200" kern="0" dirty="0">
-                <a:solidFill>
-                  <a:srgbClr val="2563EB"/>
-                </a:solidFill>
-              </a:rPr>
-              <a:t>FORMATO EM GRUPO · ATÉ 3 PESSOAS</a:t>
-            </a:r>
-            <a:endParaRPr lang="en-US" sz="1200" dirty="0"/>
-          </a:p>
-        </p:txBody>
-      </p:sp>
-      <p:sp>
-        <p:nvSpPr>
-          <p:cNvPr id="3" name="Text 1"/>
-          <p:cNvSpPr/>
-          <p:nvPr/>
-        </p:nvSpPr>
-        <p:spPr>
-          <a:xfrm>
-            <a:off x="0" y="530352"/>
-            <a:ext cx="12191695" cy="457200"/>
-          </a:xfrm>
-          <a:prstGeom prst="rect">
-            <a:avLst/>
-          </a:prstGeom>
-          <a:noFill/>
-          <a:ln/>
-        </p:spPr>
-        <p:txBody>
-          <a:bodyPr wrap="square" rtlCol="0" anchor="ctr"/>
-          <a:lstStyle/>
-          <a:p>
-            <a:pPr algn="ctr" indent="0" marL="0">
-              <a:buNone/>
-            </a:pPr>
-            <a:r>
-              <a:rPr lang="en-US" sz="2600" b="1" dirty="0">
-                <a:solidFill>
-                  <a:srgbClr val="0F172A"/>
-                </a:solidFill>
-              </a:rPr>
-              <a:t>Uma opção mais acessível</a:t>
-            </a:r>
-            <a:endParaRPr lang="en-US" sz="2600" dirty="0"/>
-          </a:p>
-        </p:txBody>
-      </p:sp>
-      <p:sp>
-        <p:nvSpPr>
-          <p:cNvPr id="4" name="Shape 2"/>
-          <p:cNvSpPr/>
-          <p:nvPr/>
-        </p:nvSpPr>
-        <p:spPr>
-          <a:xfrm>
-            <a:off x="5775808" y="1024128"/>
-            <a:ext cx="640080" cy="54864"/>
-          </a:xfrm>
-          <a:prstGeom prst="roundRect">
-            <a:avLst>
-              <a:gd name="adj" fmla="val 50000"/>
-            </a:avLst>
-          </a:prstGeom>
-          <a:solidFill>
-            <a:srgbClr val="2563EB"/>
-          </a:solidFill>
-          <a:ln/>
-        </p:spPr>
-      </p:sp>
-      <p:sp>
-        <p:nvSpPr>
-          <p:cNvPr id="5" name="Shape 3"/>
-          <p:cNvSpPr/>
-          <p:nvPr/>
-        </p:nvSpPr>
-        <p:spPr>
-          <a:xfrm>
-            <a:off x="792328" y="1463040"/>
-            <a:ext cx="3383280" cy="3154680"/>
-          </a:xfrm>
-          <a:prstGeom prst="roundRect">
-            <a:avLst>
-              <a:gd name="adj" fmla="val 3478"/>
-            </a:avLst>
-          </a:prstGeom>
-          <a:solidFill>
-            <a:srgbClr val="FFFFFF"/>
-          </a:solidFill>
-          <a:ln w="12700">
-            <a:solidFill>
-              <a:srgbClr val="F1F5F9"/>
-            </a:solidFill>
-            <a:prstDash val="solid"/>
-          </a:ln>
-          <a:effectLst>
-            <a:outerShdw sx="100000" sy="100000" kx="0" ky="0" algn="bl" rotWithShape="0" blurRad="101600" dist="38100" dir="5400000">
-              <a:srgbClr val="000000">
-                <a:alpha val="8000"/>
-              </a:srgbClr>
-            </a:outerShdw>
-          </a:effectLst>
-        </p:spPr>
-      </p:sp>
-      <p:sp>
-        <p:nvSpPr>
-          <p:cNvPr id="6" name="Shape 4"/>
-          <p:cNvSpPr/>
-          <p:nvPr/>
-        </p:nvSpPr>
-        <p:spPr>
-          <a:xfrm>
-            <a:off x="1020928" y="1691640"/>
-            <a:ext cx="502920" cy="502920"/>
-          </a:xfrm>
-          <a:prstGeom prst="roundRect">
-            <a:avLst>
-              <a:gd name="adj" fmla="val 21818"/>
-            </a:avLst>
-          </a:prstGeom>
-          <a:solidFill>
-            <a:srgbClr val="EFF6FF"/>
-          </a:solidFill>
-          <a:ln/>
-        </p:spPr>
-      </p:sp>
-      <p:sp>
-        <p:nvSpPr>
-          <p:cNvPr id="7" name="Text 5"/>
-          <p:cNvSpPr/>
-          <p:nvPr/>
-        </p:nvSpPr>
-        <p:spPr>
-          <a:xfrm>
-            <a:off x="1020928" y="1691640"/>
-            <a:ext cx="502920" cy="502920"/>
-          </a:xfrm>
-          <a:prstGeom prst="rect">
-            <a:avLst/>
-          </a:prstGeom>
-          <a:noFill/>
-          <a:ln/>
-        </p:spPr>
-        <p:txBody>
-          <a:bodyPr wrap="square" rtlCol="0" anchor="ctr"/>
-          <a:lstStyle/>
-          <a:p>
-            <a:pPr algn="ctr" indent="0" marL="0">
-              <a:buNone/>
-            </a:pPr>
-            <a:r>
-              <a:rPr lang="en-US" sz="1600" dirty="0">
-                <a:solidFill>
-                  <a:srgbClr val="000000"/>
-                </a:solidFill>
-              </a:rPr>
-              <a:t>👤</a:t>
-            </a:r>
-            <a:endParaRPr lang="en-US" sz="1600" dirty="0"/>
-          </a:p>
-        </p:txBody>
-      </p:sp>
-      <p:sp>
-        <p:nvSpPr>
-          <p:cNvPr id="8" name="Text 6"/>
-          <p:cNvSpPr/>
-          <p:nvPr/>
-        </p:nvSpPr>
-        <p:spPr>
-          <a:xfrm>
-            <a:off x="1020928" y="2286000"/>
-            <a:ext cx="2926080" cy="228600"/>
-          </a:xfrm>
-          <a:prstGeom prst="rect">
-            <a:avLst/>
-          </a:prstGeom>
-          <a:noFill/>
-          <a:ln/>
-        </p:spPr>
-        <p:txBody>
-          <a:bodyPr wrap="square" rtlCol="0" anchor="ctr"/>
-          <a:lstStyle/>
-          <a:p>
-            <a:pPr indent="0" marL="0">
-              <a:buNone/>
-            </a:pPr>
-            <a:r>
-              <a:rPr lang="en-US" sz="950" b="1" spc="100" kern="0" dirty="0">
-                <a:solidFill>
-                  <a:srgbClr val="1D4ED8"/>
-                </a:solidFill>
-              </a:rPr>
-              <a:t>MÓDULO 1</a:t>
-            </a:r>
-            <a:endParaRPr lang="en-US" sz="950" dirty="0"/>
-          </a:p>
-        </p:txBody>
-      </p:sp>
-      <p:sp>
-        <p:nvSpPr>
-          <p:cNvPr id="9" name="Text 7"/>
-          <p:cNvSpPr/>
-          <p:nvPr/>
-        </p:nvSpPr>
-        <p:spPr>
-          <a:xfrm>
-            <a:off x="1020928" y="2514600"/>
-            <a:ext cx="2926080" cy="640080"/>
-          </a:xfrm>
-          <a:prstGeom prst="rect">
-            <a:avLst/>
-          </a:prstGeom>
-          <a:noFill/>
-          <a:ln/>
-        </p:spPr>
-        <p:txBody>
-          <a:bodyPr wrap="square" rtlCol="0" anchor="ctr"/>
-          <a:lstStyle/>
-          <a:p>
-            <a:pPr indent="0" marL="0">
-              <a:buNone/>
-            </a:pPr>
-            <a:r>
-              <a:rPr lang="en-US" sz="1450" b="1" dirty="0">
-                <a:solidFill>
-                  <a:srgbClr val="0F172A"/>
-                </a:solidFill>
-              </a:rPr>
-              <a:t>Quem sou como empreendedor? *</a:t>
-            </a:r>
-            <a:endParaRPr lang="en-US" sz="1450" dirty="0"/>
-          </a:p>
-        </p:txBody>
-      </p:sp>
-      <p:sp>
-        <p:nvSpPr>
-          <p:cNvPr id="10" name="Text 8"/>
-          <p:cNvSpPr/>
-          <p:nvPr/>
-        </p:nvSpPr>
-        <p:spPr>
-          <a:xfrm>
-            <a:off x="1020928" y="3154680"/>
-            <a:ext cx="2926080" cy="685800"/>
-          </a:xfrm>
-          <a:prstGeom prst="rect">
-            <a:avLst/>
-          </a:prstGeom>
-          <a:noFill/>
-          <a:ln/>
-        </p:spPr>
-        <p:txBody>
-          <a:bodyPr wrap="square" rtlCol="0" anchor="ctr"/>
-          <a:lstStyle/>
-          <a:p>
-            <a:pPr marL="342900" indent="-342900">
-              <a:lnSpc>
-                <a:spcPts val="1500"/>
-              </a:lnSpc>
-              <a:buSzPct val="100000"/>
-              <a:buChar char="•"/>
-            </a:pPr>
-            <a:r>
-              <a:rPr lang="en-US" sz="1050" dirty="0">
-                <a:solidFill>
-                  <a:srgbClr val="475569"/>
-                </a:solidFill>
-              </a:rPr>
-              <a:t>4 encontros</a:t>
-            </a:r>
-            <a:endParaRPr lang="en-US" sz="1050" dirty="0"/>
-          </a:p>
-          <a:p>
-            <a:pPr marL="342900" indent="-342900">
-              <a:lnSpc>
-                <a:spcPts val="1500"/>
-              </a:lnSpc>
-              <a:buSzPct val="100000"/>
-              <a:buChar char="•"/>
-            </a:pPr>
-            <a:r>
-              <a:rPr lang="en-US" sz="1050" dirty="0">
-                <a:solidFill>
-                  <a:srgbClr val="475569"/>
-                </a:solidFill>
-              </a:rPr>
-              <a:t>Duração: 4 semanas</a:t>
-            </a:r>
-            <a:endParaRPr lang="en-US" sz="1050" dirty="0"/>
-          </a:p>
-        </p:txBody>
-      </p:sp>
-      <p:sp>
-        <p:nvSpPr>
-          <p:cNvPr id="11" name="Shape 9"/>
-          <p:cNvSpPr/>
-          <p:nvPr/>
-        </p:nvSpPr>
-        <p:spPr>
-          <a:xfrm>
-            <a:off x="1020928" y="3703320"/>
-            <a:ext cx="2926080" cy="731520"/>
-          </a:xfrm>
-          <a:prstGeom prst="roundRect">
-            <a:avLst>
-              <a:gd name="adj" fmla="val 15000"/>
-            </a:avLst>
-          </a:prstGeom>
-          <a:solidFill>
-            <a:srgbClr val="F8FAFC"/>
-          </a:solidFill>
-          <a:ln/>
-        </p:spPr>
-      </p:sp>
-      <p:sp>
-        <p:nvSpPr>
-          <p:cNvPr id="12" name="Text 10"/>
-          <p:cNvSpPr/>
-          <p:nvPr/>
-        </p:nvSpPr>
-        <p:spPr>
-          <a:xfrm>
-            <a:off x="1158088" y="3776472"/>
-            <a:ext cx="2651760" cy="201168"/>
-          </a:xfrm>
-          <a:prstGeom prst="rect">
-            <a:avLst/>
-          </a:prstGeom>
-          <a:noFill/>
-          <a:ln/>
-        </p:spPr>
-        <p:txBody>
-          <a:bodyPr wrap="square" rtlCol="0" anchor="ctr"/>
-          <a:lstStyle/>
-          <a:p>
-            <a:pPr indent="0" marL="0">
-              <a:buNone/>
-            </a:pPr>
-            <a:r>
-              <a:rPr lang="en-US" sz="900" dirty="0">
-                <a:solidFill>
-                  <a:srgbClr val="64748B"/>
-                </a:solidFill>
-              </a:rPr>
-              <a:t>Investimento por pessoa</a:t>
-            </a:r>
-            <a:endParaRPr lang="en-US" sz="900" dirty="0"/>
-          </a:p>
-        </p:txBody>
-      </p:sp>
-      <p:sp>
-        <p:nvSpPr>
-          <p:cNvPr id="13" name="Text 11"/>
-          <p:cNvSpPr/>
-          <p:nvPr/>
-        </p:nvSpPr>
-        <p:spPr>
-          <a:xfrm>
-            <a:off x="1158088" y="3959352"/>
-            <a:ext cx="2651760" cy="365760"/>
-          </a:xfrm>
-          <a:prstGeom prst="rect">
-            <a:avLst/>
-          </a:prstGeom>
-          <a:noFill/>
-          <a:ln/>
-        </p:spPr>
-        <p:txBody>
-          <a:bodyPr wrap="square" rtlCol="0" anchor="ctr"/>
-          <a:lstStyle/>
-          <a:p>
-            <a:pPr indent="0" marL="0">
-              <a:buNone/>
-            </a:pPr>
-            <a:r>
-              <a:rPr lang="en-US" sz="2000" b="1" dirty="0">
-                <a:solidFill>
-                  <a:srgbClr val="1D4ED8"/>
-                </a:solidFill>
-              </a:rPr>
-              <a:t>R$ 1.350</a:t>
-            </a:r>
-            <a:endParaRPr lang="en-US" sz="2000" dirty="0"/>
-          </a:p>
-        </p:txBody>
-      </p:sp>
-      <p:sp>
-        <p:nvSpPr>
-          <p:cNvPr id="14" name="Shape 12"/>
-          <p:cNvSpPr/>
-          <p:nvPr/>
-        </p:nvSpPr>
-        <p:spPr>
-          <a:xfrm>
-            <a:off x="4404208" y="1463040"/>
-            <a:ext cx="3383280" cy="3154680"/>
-          </a:xfrm>
-          <a:prstGeom prst="roundRect">
-            <a:avLst>
-              <a:gd name="adj" fmla="val 3478"/>
-            </a:avLst>
-          </a:prstGeom>
-          <a:solidFill>
-            <a:srgbClr val="FFFFFF"/>
-          </a:solidFill>
-          <a:ln w="12700">
-            <a:solidFill>
-              <a:srgbClr val="F1F5F9"/>
-            </a:solidFill>
-            <a:prstDash val="solid"/>
-          </a:ln>
-          <a:effectLst>
-            <a:outerShdw sx="100000" sy="100000" kx="0" ky="0" algn="bl" rotWithShape="0" blurRad="101600" dist="38100" dir="5400000">
-              <a:srgbClr val="000000">
-                <a:alpha val="8000"/>
-              </a:srgbClr>
-            </a:outerShdw>
-          </a:effectLst>
-        </p:spPr>
-      </p:sp>
-      <p:sp>
-        <p:nvSpPr>
-          <p:cNvPr id="15" name="Shape 13"/>
-          <p:cNvSpPr/>
-          <p:nvPr/>
-        </p:nvSpPr>
-        <p:spPr>
-          <a:xfrm>
-            <a:off x="4632808" y="1691640"/>
-            <a:ext cx="502920" cy="502920"/>
-          </a:xfrm>
-          <a:prstGeom prst="roundRect">
-            <a:avLst>
-              <a:gd name="adj" fmla="val 21818"/>
-            </a:avLst>
-          </a:prstGeom>
-          <a:solidFill>
-            <a:srgbClr val="EEF2FF"/>
-          </a:solidFill>
-          <a:ln/>
-        </p:spPr>
-      </p:sp>
-      <p:sp>
-        <p:nvSpPr>
-          <p:cNvPr id="16" name="Text 14"/>
-          <p:cNvSpPr/>
-          <p:nvPr/>
-        </p:nvSpPr>
-        <p:spPr>
-          <a:xfrm>
-            <a:off x="4632808" y="1691640"/>
-            <a:ext cx="502920" cy="502920"/>
-          </a:xfrm>
-          <a:prstGeom prst="rect">
-            <a:avLst/>
-          </a:prstGeom>
-          <a:noFill/>
-          <a:ln/>
-        </p:spPr>
-        <p:txBody>
-          <a:bodyPr wrap="square" rtlCol="0" anchor="ctr"/>
-          <a:lstStyle/>
-          <a:p>
-            <a:pPr algn="ctr" indent="0" marL="0">
-              <a:buNone/>
-            </a:pPr>
-            <a:r>
-              <a:rPr lang="en-US" sz="1600" dirty="0">
-                <a:solidFill>
-                  <a:srgbClr val="000000"/>
-                </a:solidFill>
-              </a:rPr>
-              <a:t>🎯</a:t>
-            </a:r>
-            <a:endParaRPr lang="en-US" sz="1600" dirty="0"/>
-          </a:p>
-        </p:txBody>
-      </p:sp>
-      <p:sp>
-        <p:nvSpPr>
-          <p:cNvPr id="17" name="Text 15"/>
-          <p:cNvSpPr/>
-          <p:nvPr/>
-        </p:nvSpPr>
-        <p:spPr>
-          <a:xfrm>
-            <a:off x="4632808" y="2286000"/>
-            <a:ext cx="2926080" cy="228600"/>
-          </a:xfrm>
-          <a:prstGeom prst="rect">
-            <a:avLst/>
-          </a:prstGeom>
-          <a:noFill/>
-          <a:ln/>
-        </p:spPr>
-        <p:txBody>
-          <a:bodyPr wrap="square" rtlCol="0" anchor="ctr"/>
-          <a:lstStyle/>
-          <a:p>
-            <a:pPr indent="0" marL="0">
-              <a:buNone/>
-            </a:pPr>
-            <a:r>
-              <a:rPr lang="en-US" sz="950" b="1" spc="100" kern="0" dirty="0">
-                <a:solidFill>
-                  <a:srgbClr val="4338CA"/>
-                </a:solidFill>
-              </a:rPr>
-              <a:t>MÓDULO 2</a:t>
-            </a:r>
-            <a:endParaRPr lang="en-US" sz="950" dirty="0"/>
-          </a:p>
-        </p:txBody>
-      </p:sp>
-      <p:sp>
-        <p:nvSpPr>
-          <p:cNvPr id="18" name="Text 16"/>
-          <p:cNvSpPr/>
-          <p:nvPr/>
-        </p:nvSpPr>
-        <p:spPr>
-          <a:xfrm>
-            <a:off x="4632808" y="2514600"/>
-            <a:ext cx="2926080" cy="640080"/>
-          </a:xfrm>
-          <a:prstGeom prst="rect">
-            <a:avLst/>
-          </a:prstGeom>
-          <a:noFill/>
-          <a:ln/>
-        </p:spPr>
-        <p:txBody>
-          <a:bodyPr wrap="square" rtlCol="0" anchor="ctr"/>
-          <a:lstStyle/>
-          <a:p>
-            <a:pPr indent="0" marL="0">
-              <a:buNone/>
-            </a:pPr>
-            <a:r>
-              <a:rPr lang="en-US" sz="1450" b="1" dirty="0">
-                <a:solidFill>
-                  <a:srgbClr val="0F172A"/>
-                </a:solidFill>
-              </a:rPr>
-              <a:t>Minha estratégia como empreendedor</a:t>
-            </a:r>
-            <a:endParaRPr lang="en-US" sz="1450" dirty="0"/>
-          </a:p>
-        </p:txBody>
-      </p:sp>
-      <p:sp>
-        <p:nvSpPr>
-          <p:cNvPr id="19" name="Text 17"/>
-          <p:cNvSpPr/>
-          <p:nvPr/>
-        </p:nvSpPr>
-        <p:spPr>
-          <a:xfrm>
-            <a:off x="4632808" y="3154680"/>
-            <a:ext cx="2926080" cy="685800"/>
-          </a:xfrm>
-          <a:prstGeom prst="rect">
-            <a:avLst/>
-          </a:prstGeom>
-          <a:noFill/>
-          <a:ln/>
-        </p:spPr>
-        <p:txBody>
-          <a:bodyPr wrap="square" rtlCol="0" anchor="ctr"/>
-          <a:lstStyle/>
-          <a:p>
-            <a:pPr marL="342900" indent="-342900">
-              <a:lnSpc>
-                <a:spcPts val="1500"/>
-              </a:lnSpc>
-              <a:buSzPct val="100000"/>
-              <a:buChar char="•"/>
-            </a:pPr>
-            <a:r>
-              <a:rPr lang="en-US" sz="1050" dirty="0">
-                <a:solidFill>
-                  <a:srgbClr val="475569"/>
-                </a:solidFill>
-              </a:rPr>
-              <a:t>3 encontros</a:t>
-            </a:r>
-            <a:endParaRPr lang="en-US" sz="1050" dirty="0"/>
-          </a:p>
-          <a:p>
-            <a:pPr marL="342900" indent="-342900">
-              <a:lnSpc>
-                <a:spcPts val="1500"/>
-              </a:lnSpc>
-              <a:buSzPct val="100000"/>
-              <a:buChar char="•"/>
-            </a:pPr>
-            <a:r>
-              <a:rPr lang="en-US" sz="1050" dirty="0">
-                <a:solidFill>
-                  <a:srgbClr val="475569"/>
-                </a:solidFill>
-              </a:rPr>
-              <a:t>Duração: 4 semanas</a:t>
-            </a:r>
-            <a:endParaRPr lang="en-US" sz="1050" dirty="0"/>
-          </a:p>
-        </p:txBody>
-      </p:sp>
-      <p:sp>
-        <p:nvSpPr>
-          <p:cNvPr id="20" name="Shape 18"/>
-          <p:cNvSpPr/>
-          <p:nvPr/>
-        </p:nvSpPr>
-        <p:spPr>
-          <a:xfrm>
-            <a:off x="4632808" y="3703320"/>
-            <a:ext cx="2926080" cy="731520"/>
-          </a:xfrm>
-          <a:prstGeom prst="roundRect">
-            <a:avLst>
-              <a:gd name="adj" fmla="val 15000"/>
-            </a:avLst>
-          </a:prstGeom>
-          <a:solidFill>
-            <a:srgbClr val="F8FAFC"/>
-          </a:solidFill>
-          <a:ln/>
-        </p:spPr>
-      </p:sp>
-      <p:sp>
-        <p:nvSpPr>
-          <p:cNvPr id="21" name="Text 19"/>
-          <p:cNvSpPr/>
-          <p:nvPr/>
-        </p:nvSpPr>
-        <p:spPr>
-          <a:xfrm>
-            <a:off x="4769968" y="3776472"/>
-            <a:ext cx="2651760" cy="201168"/>
-          </a:xfrm>
-          <a:prstGeom prst="rect">
-            <a:avLst/>
-          </a:prstGeom>
-          <a:noFill/>
-          <a:ln/>
-        </p:spPr>
-        <p:txBody>
-          <a:bodyPr wrap="square" rtlCol="0" anchor="ctr"/>
-          <a:lstStyle/>
-          <a:p>
-            <a:pPr indent="0" marL="0">
-              <a:buNone/>
-            </a:pPr>
-            <a:r>
-              <a:rPr lang="en-US" sz="900" dirty="0">
-                <a:solidFill>
-                  <a:srgbClr val="64748B"/>
-                </a:solidFill>
-              </a:rPr>
-              <a:t>Investimento por pessoa</a:t>
-            </a:r>
-            <a:endParaRPr lang="en-US" sz="900" dirty="0"/>
-          </a:p>
-        </p:txBody>
-      </p:sp>
-      <p:sp>
-        <p:nvSpPr>
-          <p:cNvPr id="22" name="Text 20"/>
-          <p:cNvSpPr/>
-          <p:nvPr/>
-        </p:nvSpPr>
-        <p:spPr>
-          <a:xfrm>
-            <a:off x="4769968" y="3959352"/>
-            <a:ext cx="2651760" cy="365760"/>
-          </a:xfrm>
-          <a:prstGeom prst="rect">
-            <a:avLst/>
-          </a:prstGeom>
-          <a:noFill/>
-          <a:ln/>
-        </p:spPr>
-        <p:txBody>
-          <a:bodyPr wrap="square" rtlCol="0" anchor="ctr"/>
-          <a:lstStyle/>
-          <a:p>
-            <a:pPr indent="0" marL="0">
-              <a:buNone/>
-            </a:pPr>
-            <a:r>
-              <a:rPr lang="en-US" sz="2000" b="1" dirty="0">
-                <a:solidFill>
-                  <a:srgbClr val="4338CA"/>
-                </a:solidFill>
-              </a:rPr>
-              <a:t>R$ 1.000</a:t>
-            </a:r>
-            <a:endParaRPr lang="en-US" sz="2000" dirty="0"/>
-          </a:p>
-        </p:txBody>
-      </p:sp>
-      <p:sp>
-        <p:nvSpPr>
-          <p:cNvPr id="23" name="Shape 21"/>
-          <p:cNvSpPr/>
-          <p:nvPr/>
-        </p:nvSpPr>
-        <p:spPr>
-          <a:xfrm>
-            <a:off x="8016088" y="1463040"/>
-            <a:ext cx="3383280" cy="3154680"/>
-          </a:xfrm>
-          <a:prstGeom prst="roundRect">
-            <a:avLst>
-              <a:gd name="adj" fmla="val 3478"/>
-            </a:avLst>
-          </a:prstGeom>
-          <a:solidFill>
-            <a:srgbClr val="EFF6FF"/>
-          </a:solidFill>
-          <a:ln w="19050">
-            <a:solidFill>
-              <a:srgbClr val="2563EB"/>
-            </a:solidFill>
-            <a:prstDash val="solid"/>
-          </a:ln>
-          <a:effectLst>
-            <a:outerShdw sx="100000" sy="100000" kx="0" ky="0" algn="bl" rotWithShape="0" blurRad="101600" dist="38100" dir="5400000">
-              <a:srgbClr val="000000">
-                <a:alpha val="8000"/>
-              </a:srgbClr>
-            </a:outerShdw>
-          </a:effectLst>
-        </p:spPr>
-      </p:sp>
-      <p:sp>
-        <p:nvSpPr>
-          <p:cNvPr id="24" name="Shape 22"/>
-          <p:cNvSpPr/>
-          <p:nvPr/>
-        </p:nvSpPr>
-        <p:spPr>
-          <a:xfrm>
-            <a:off x="9707728" y="1298448"/>
-            <a:ext cx="1554480" cy="329184"/>
-          </a:xfrm>
-          <a:prstGeom prst="roundRect">
-            <a:avLst>
-              <a:gd name="adj" fmla="val 50000"/>
-            </a:avLst>
-          </a:prstGeom>
-          <a:solidFill>
-            <a:srgbClr val="1D4ED8"/>
-          </a:solidFill>
-          <a:ln/>
-        </p:spPr>
-      </p:sp>
-      <p:sp>
-        <p:nvSpPr>
-          <p:cNvPr id="25" name="Text 23"/>
-          <p:cNvSpPr/>
-          <p:nvPr/>
-        </p:nvSpPr>
-        <p:spPr>
-          <a:xfrm>
-            <a:off x="9707728" y="1298448"/>
-            <a:ext cx="1554480" cy="329184"/>
-          </a:xfrm>
-          <a:prstGeom prst="rect">
-            <a:avLst/>
-          </a:prstGeom>
-          <a:noFill/>
-          <a:ln/>
-        </p:spPr>
-        <p:txBody>
-          <a:bodyPr wrap="square" rtlCol="0" anchor="ctr"/>
-          <a:lstStyle/>
-          <a:p>
-            <a:pPr algn="ctr" indent="0" marL="0">
-              <a:buNone/>
-            </a:pPr>
-            <a:r>
-              <a:rPr lang="en-US" sz="800" b="1" dirty="0">
-                <a:solidFill>
-                  <a:srgbClr val="FFFFFF"/>
-                </a:solidFill>
-              </a:rPr>
-              <a:t>MELHOR ESCOLHA</a:t>
-            </a:r>
-            <a:endParaRPr lang="en-US" sz="800" dirty="0"/>
-          </a:p>
-        </p:txBody>
-      </p:sp>
-      <p:sp>
-        <p:nvSpPr>
-          <p:cNvPr id="26" name="Shape 24"/>
-          <p:cNvSpPr/>
-          <p:nvPr/>
-        </p:nvSpPr>
-        <p:spPr>
-          <a:xfrm>
-            <a:off x="8244688" y="1691640"/>
-            <a:ext cx="502920" cy="502920"/>
-          </a:xfrm>
-          <a:prstGeom prst="roundRect">
-            <a:avLst>
-              <a:gd name="adj" fmla="val 21818"/>
-            </a:avLst>
-          </a:prstGeom>
-          <a:solidFill>
-            <a:srgbClr val="2563EB"/>
-          </a:solidFill>
-          <a:ln/>
-        </p:spPr>
-      </p:sp>
-      <p:sp>
-        <p:nvSpPr>
-          <p:cNvPr id="27" name="Text 25"/>
-          <p:cNvSpPr/>
-          <p:nvPr/>
-        </p:nvSpPr>
-        <p:spPr>
-          <a:xfrm>
-            <a:off x="8244688" y="1691640"/>
-            <a:ext cx="502920" cy="502920"/>
-          </a:xfrm>
-          <a:prstGeom prst="rect">
-            <a:avLst/>
-          </a:prstGeom>
-          <a:noFill/>
-          <a:ln/>
-        </p:spPr>
-        <p:txBody>
-          <a:bodyPr wrap="square" rtlCol="0" anchor="ctr"/>
-          <a:lstStyle/>
-          <a:p>
-            <a:pPr algn="ctr" indent="0" marL="0">
-              <a:buNone/>
-            </a:pPr>
-            <a:r>
-              <a:rPr lang="en-US" sz="1600" dirty="0">
-                <a:solidFill>
-                  <a:srgbClr val="000000"/>
-                </a:solidFill>
-              </a:rPr>
-              <a:t>⭐</a:t>
-            </a:r>
-            <a:endParaRPr lang="en-US" sz="1600" dirty="0"/>
-          </a:p>
-        </p:txBody>
-      </p:sp>
-      <p:sp>
-        <p:nvSpPr>
-          <p:cNvPr id="28" name="Text 26"/>
-          <p:cNvSpPr/>
-          <p:nvPr/>
-        </p:nvSpPr>
-        <p:spPr>
-          <a:xfrm>
-            <a:off x="8244688" y="2286000"/>
-            <a:ext cx="2926080" cy="228600"/>
-          </a:xfrm>
-          <a:prstGeom prst="rect">
-            <a:avLst/>
-          </a:prstGeom>
-          <a:noFill/>
-          <a:ln/>
-        </p:spPr>
-        <p:txBody>
-          <a:bodyPr wrap="square" rtlCol="0" anchor="ctr"/>
-          <a:lstStyle/>
-          <a:p>
-            <a:pPr indent="0" marL="0">
-              <a:buNone/>
-            </a:pPr>
-            <a:r>
-              <a:rPr lang="en-US" sz="950" b="1" spc="100" kern="0" dirty="0">
-                <a:solidFill>
-                  <a:srgbClr val="1D4ED8"/>
-                </a:solidFill>
-              </a:rPr>
-              <a:t>MÓDULO 1 + MÓDULO 2</a:t>
-            </a:r>
-            <a:endParaRPr lang="en-US" sz="950" dirty="0"/>
-          </a:p>
-        </p:txBody>
-      </p:sp>
-      <p:sp>
-        <p:nvSpPr>
-          <p:cNvPr id="29" name="Text 27"/>
-          <p:cNvSpPr/>
-          <p:nvPr/>
-        </p:nvSpPr>
-        <p:spPr>
-          <a:xfrm>
-            <a:off x="8244688" y="2514600"/>
-            <a:ext cx="2926080" cy="640080"/>
-          </a:xfrm>
-          <a:prstGeom prst="rect">
-            <a:avLst/>
-          </a:prstGeom>
-          <a:noFill/>
-          <a:ln/>
-        </p:spPr>
-        <p:txBody>
-          <a:bodyPr wrap="square" rtlCol="0" anchor="ctr"/>
-          <a:lstStyle/>
-          <a:p>
-            <a:pPr indent="0" marL="0">
-              <a:buNone/>
-            </a:pPr>
-            <a:r>
-              <a:rPr lang="en-US" sz="1450" b="1" dirty="0">
-                <a:solidFill>
-                  <a:srgbClr val="0F172A"/>
-                </a:solidFill>
-              </a:rPr>
-              <a:t>Programa Completo *</a:t>
-            </a:r>
-            <a:endParaRPr lang="en-US" sz="1450" dirty="0"/>
-          </a:p>
-        </p:txBody>
-      </p:sp>
-      <p:sp>
-        <p:nvSpPr>
-          <p:cNvPr id="30" name="Text 28"/>
-          <p:cNvSpPr/>
-          <p:nvPr/>
-        </p:nvSpPr>
-        <p:spPr>
-          <a:xfrm>
-            <a:off x="8244688" y="3154680"/>
-            <a:ext cx="2926080" cy="685800"/>
-          </a:xfrm>
-          <a:prstGeom prst="rect">
-            <a:avLst/>
-          </a:prstGeom>
-          <a:noFill/>
-          <a:ln/>
-        </p:spPr>
-        <p:txBody>
-          <a:bodyPr wrap="square" rtlCol="0" anchor="ctr"/>
-          <a:lstStyle/>
-          <a:p>
-            <a:pPr marL="342900" indent="-342900">
-              <a:lnSpc>
-                <a:spcPts val="1500"/>
-              </a:lnSpc>
-              <a:buSzPct val="100000"/>
-              <a:buChar char="•"/>
-            </a:pPr>
-            <a:r>
-              <a:rPr lang="en-US" sz="1050" dirty="0">
-                <a:solidFill>
-                  <a:srgbClr val="475569"/>
-                </a:solidFill>
-              </a:rPr>
-              <a:t>7 encontros</a:t>
-            </a:r>
-            <a:endParaRPr lang="en-US" sz="1050" dirty="0"/>
-          </a:p>
-          <a:p>
-            <a:pPr marL="342900" indent="-342900">
-              <a:lnSpc>
-                <a:spcPts val="1500"/>
-              </a:lnSpc>
-              <a:buSzPct val="100000"/>
-              <a:buChar char="•"/>
-            </a:pPr>
-            <a:r>
-              <a:rPr lang="en-US" sz="1050" dirty="0">
-                <a:solidFill>
-                  <a:srgbClr val="475569"/>
-                </a:solidFill>
-              </a:rPr>
-              <a:t>Duração: 8 semanas</a:t>
-            </a:r>
-            <a:endParaRPr lang="en-US" sz="1050" dirty="0"/>
-          </a:p>
-        </p:txBody>
-      </p:sp>
-      <p:sp>
-        <p:nvSpPr>
-          <p:cNvPr id="31" name="Shape 29"/>
-          <p:cNvSpPr/>
-          <p:nvPr/>
-        </p:nvSpPr>
-        <p:spPr>
-          <a:xfrm>
-            <a:off x="8244688" y="3703320"/>
-            <a:ext cx="2926080" cy="731520"/>
-          </a:xfrm>
-          <a:prstGeom prst="roundRect">
-            <a:avLst>
-              <a:gd name="adj" fmla="val 15000"/>
-            </a:avLst>
-          </a:prstGeom>
-          <a:solidFill>
-            <a:srgbClr val="FFFFFF"/>
-          </a:solidFill>
-          <a:ln/>
-        </p:spPr>
-      </p:sp>
-      <p:sp>
-        <p:nvSpPr>
-          <p:cNvPr id="32" name="Text 30"/>
-          <p:cNvSpPr/>
-          <p:nvPr/>
-        </p:nvSpPr>
-        <p:spPr>
-          <a:xfrm>
-            <a:off x="8381848" y="3776472"/>
-            <a:ext cx="2651760" cy="201168"/>
-          </a:xfrm>
-          <a:prstGeom prst="rect">
-            <a:avLst/>
-          </a:prstGeom>
-          <a:noFill/>
-          <a:ln/>
-        </p:spPr>
-        <p:txBody>
-          <a:bodyPr wrap="square" rtlCol="0" anchor="ctr"/>
-          <a:lstStyle/>
-          <a:p>
-            <a:pPr indent="0" marL="0">
-              <a:buNone/>
-            </a:pPr>
-            <a:r>
-              <a:rPr lang="en-US" sz="900" dirty="0">
-                <a:solidFill>
-                  <a:srgbClr val="64748B"/>
-                </a:solidFill>
-              </a:rPr>
-              <a:t>Investimento por pessoa</a:t>
-            </a:r>
-            <a:endParaRPr lang="en-US" sz="900" dirty="0"/>
-          </a:p>
-        </p:txBody>
-      </p:sp>
-      <p:sp>
-        <p:nvSpPr>
-          <p:cNvPr id="33" name="Text 31"/>
-          <p:cNvSpPr/>
-          <p:nvPr/>
-        </p:nvSpPr>
-        <p:spPr>
-          <a:xfrm>
-            <a:off x="8381848" y="3959352"/>
-            <a:ext cx="2651760" cy="365760"/>
-          </a:xfrm>
-          <a:prstGeom prst="rect">
-            <a:avLst/>
-          </a:prstGeom>
-          <a:noFill/>
-          <a:ln/>
-        </p:spPr>
-        <p:txBody>
-          <a:bodyPr wrap="square" rtlCol="0" anchor="ctr"/>
-          <a:lstStyle/>
-          <a:p>
-            <a:pPr indent="0" marL="0">
-              <a:buNone/>
-            </a:pPr>
-            <a:r>
-              <a:rPr lang="en-US" sz="2000" b="1" dirty="0">
-                <a:solidFill>
-                  <a:srgbClr val="1D4ED8"/>
-                </a:solidFill>
-              </a:rPr>
-              <a:t>R$ 2.000</a:t>
-            </a:r>
-            <a:endParaRPr lang="en-US" sz="2000" dirty="0"/>
-          </a:p>
-        </p:txBody>
-      </p:sp>
-      <p:sp>
-        <p:nvSpPr>
-          <p:cNvPr id="34" name="Text 32"/>
-          <p:cNvSpPr/>
-          <p:nvPr/>
-        </p:nvSpPr>
-        <p:spPr>
-          <a:xfrm>
-            <a:off x="8381848" y="4325112"/>
-            <a:ext cx="2651760" cy="228600"/>
-          </a:xfrm>
-          <a:prstGeom prst="rect">
-            <a:avLst/>
-          </a:prstGeom>
-          <a:noFill/>
-          <a:ln/>
-        </p:spPr>
-        <p:txBody>
-          <a:bodyPr wrap="square" rtlCol="0" anchor="ctr"/>
-          <a:lstStyle/>
-          <a:p>
-            <a:pPr indent="0" marL="0">
-              <a:buNone/>
-            </a:pPr>
-            <a:r>
-              <a:rPr lang="en-US" sz="900" b="1" dirty="0">
-                <a:solidFill>
-                  <a:srgbClr val="059669"/>
-                </a:solidFill>
-              </a:rPr>
-              <a:t>✨ Economia de R$ 350</a:t>
-            </a:r>
-            <a:endParaRPr lang="en-US" sz="900" dirty="0"/>
-          </a:p>
-        </p:txBody>
-      </p:sp>
-      <p:sp>
-        <p:nvSpPr>
-          <p:cNvPr id="35" name="Text 33"/>
-          <p:cNvSpPr/>
-          <p:nvPr/>
-        </p:nvSpPr>
-        <p:spPr>
-          <a:xfrm>
-            <a:off x="1371600" y="6355080"/>
-            <a:ext cx="9448495" cy="320040"/>
-          </a:xfrm>
-          <a:prstGeom prst="rect">
-            <a:avLst/>
-          </a:prstGeom>
-          <a:noFill/>
-          <a:ln/>
-        </p:spPr>
-        <p:txBody>
-          <a:bodyPr wrap="square" rtlCol="0" anchor="ctr"/>
-          <a:lstStyle/>
-          <a:p>
-            <a:pPr algn="ctr" indent="0" marL="0">
-              <a:buNone/>
-            </a:pPr>
-            <a:r>
-              <a:rPr lang="en-US" sz="1050" dirty="0">
-                <a:solidFill>
-                  <a:srgbClr val="64748B"/>
-                </a:solidFill>
-              </a:rPr>
-              <a:t>* No formato em grupo, o Módulo 1 não prevê a realização do assessment individual Gallup StrengthsFinder.</a:t>
-            </a:r>
-            <a:endParaRPr lang="en-US" sz="1050" dirty="0"/>
-          </a:p>
-        </p:txBody>
-      </p:sp>
-      <p:sp>
-        <p:nvSpPr>
-          <p:cNvPr id="36" name="Text 34"/>
+          <p:cNvPr id="38" name="Text 36"/>
           <p:cNvSpPr/>
           <p:nvPr/>
         </p:nvSpPr>

</xml_diff>